<commit_message>
VA01 sim_review live: Workbook/Trainerhandbuch/PPTX neu, sim_review=true
Co-Authored-By: Claude Opus 4.8 <noreply@anthropic.com>
</commit_message>
<xml_diff>
--- a/protected-downloads/praesentation/VA01.pptx
+++ b/protected-downloads/praesentation/VA01.pptx
@@ -5632,7 +5632,7 @@
                 </a:solidFill>
                 <a:latin typeface="Consolas"/>
               </a:rPr>
-              <a:t>01:05–01:15 </a:t>
+              <a:t>01:05–01:20 </a:t>
             </a:r>
             <a:r>
               <a:rPr sz="1500" b="1">
@@ -5669,7 +5669,7 @@
                 </a:solidFill>
                 <a:latin typeface="Consolas"/>
               </a:rPr>
-              <a:t>01:15–01:25 </a:t>
+              <a:t>01:20–01:25 </a:t>
             </a:r>
             <a:r>
               <a:rPr sz="1500" b="1">

</xml_diff>

<commit_message>
Welle 3 Pilot: VA01 kuratiertes Deck + 2 Schaubilder (Web/Admin/Workbook)
Co-Authored-By: Claude Fable 5 <noreply@anthropic.com>
</commit_message>
<xml_diff>
--- a/protected-downloads/praesentation/VA01.pptx
+++ b/protected-downloads/praesentation/VA01.pptx
@@ -13,6 +13,14 @@
     <p:sldId id="261" r:id="rId13"/>
     <p:sldId id="262" r:id="rId14"/>
     <p:sldId id="263" r:id="rId15"/>
+    <p:sldId id="264" r:id="rId16"/>
+    <p:sldId id="265" r:id="rId17"/>
+    <p:sldId id="266" r:id="rId18"/>
+    <p:sldId id="267" r:id="rId19"/>
+    <p:sldId id="268" r:id="rId20"/>
+    <p:sldId id="269" r:id="rId21"/>
+    <p:sldId id="270" r:id="rId22"/>
+    <p:sldId id="271" r:id="rId23"/>
   </p:sldIdLst>
   <p:sldSz cx="12188952" cy="6858000" type="screen4x3"/>
   <p:notesSz cx="6858000" cy="9144000"/>
@@ -579,7 +587,7 @@
           <a:lstStyle/>
           <a:p>
             <a:r>
-              <a:t>Siehe Trainerhandbuch (Sektion 3) für Moderationshinweise, Timing und erwartete Teilnehmerreaktionen.</a:t>
+              <a:t>Aktivierende Einstiegsfrage an die Gruppe: „Was ist das häufigste Defizit in einer Akte vor der Auszahlung?" Antworten sammeln, noch nicht auflösen – kommt beim Fall zurück.</a:t>
             </a:r>
           </a:p>
         </p:txBody>
@@ -649,7 +657,7 @@
           <a:lstStyle/>
           <a:p>
             <a:r>
-              <a:t>Siehe Trainerhandbuch (Sektion 3) für Moderationshinweise, Timing und erwartete Teilnehmerreaktionen.</a:t>
+              <a:t>Kernbotschaft betonen – formale Vollständigkeit ist nicht gleich ordnungsgemäße Akte. Eine veraltete BWA ist ein Mangel, auch wenn etwas hinterlegt ist.</a:t>
             </a:r>
           </a:p>
         </p:txBody>
@@ -719,32 +727,12 @@
           <a:lstStyle/>
           <a:p>
             <a:r>
-              <a:t>AB-2 Musterlösung (Trainer-Version)</a:t>
-            </a:r>
-          </a:p>
-          <a:p>
-            <a:r>
-              <a:t>Vollständig/aktuell (✓): Kreditantrag, Kreditbeschluss/Votum, Kreditvertrag, Sicherheiten/Grundbuch, HR-Auszug/KYC.</a:t>
-            </a:r>
-          </a:p>
-          <a:p>
-            <a:r>
-              <a:t>Veraltet (∼): aktuelle BWA (7 Monate – sollte ≤ 3 Monate sein), Selbstauskunft GGF (3 Jahre alt).</a:t>
-            </a:r>
-          </a:p>
-          <a:p>
-            <a:r>
-              <a:t>Fehlt (✗): zweiter Jahresabschluss (nur ein Jahr vorhanden).</a:t>
-            </a:r>
-          </a:p>
-          <a:p>
-            <a:r>
-              <a:t>Kernbefund: Die Akte ist formal und sicherheitenseitig in Ordnung, scheitert aber an der § 18 KWG-Offenlegung. Vor der Auszahlung sind nachzufordern: (1) Jahresabschluss Vor-Vorjahr, (2) aktuelle BWA, (3) aktualisierte Selbstauskunft. Erst danach ist die Akte auszahlungsreif; die Marktfolge ist über die Nachforderung zu informieren.</a:t>
-            </a:r>
-          </a:p>
-          <a:p>
-            <a:r>
-              <a:t>Trainer-Hinweis: Ziel ist nicht das Auswendiglernen einer Liste, sondern das Prinzip: formale Vollständigkeit ≠ ordnungsgemäße Akte. Lassen Sie die Teilnehmer selbst erkennen, dass die „unscheinbaren" Offenlegungsunterlagen der häufigste reale Mangel sind. Die Drei-Monats-Faustregel für die BWA ist ein Orientierungswert; die haus­interne Arbeitsanweisung geht vor.</a:t>
+              <a:t>Hausinterne Grenze thematisieren – liegt oft deutlich unter 750 TEUR (häufig 50–100 TEUR). Entscheidend für den Alltag ist, was das Haus festgelegt hat.</a:t>
+            </a:r>
+          </a:p>
+          <a:p>
+            <a:r>
+              <a:t>Erwartbare Frage „Ich dachte, das gilt erst ab einer Million" – gesetzliche Grenze klar benennen, dann auf die Kreditpolitik verweisen.</a:t>
             </a:r>
           </a:p>
         </p:txBody>
@@ -814,7 +802,302 @@
           <a:lstStyle/>
           <a:p>
             <a:r>
-              <a:t>Siehe Trainerhandbuch (Sektion 3) für Moderationshinweise, Timing und erwartete Teilnehmerreaktionen.</a:t>
+              <a:t>Fall ruhig vorstellen, dann die Gruppe selbst prüfen lassen (Einzelarbeit). Trainer geht durch den Raum, hält sich zurück, beobachtet.</a:t>
+            </a:r>
+          </a:p>
+        </p:txBody>
+      </p:sp>
+      <p:sp>
+        <p:nvSpPr>
+          <p:cNvPr id="4" name="Slide Number Placeholder 3"/>
+          <p:cNvSpPr>
+            <a:spLocks noGrp="1"/>
+          </p:cNvSpPr>
+          <p:nvPr>
+            <p:ph type="sldNum" idx="5" sz="quarter"/>
+          </p:nvPr>
+        </p:nvSpPr>
+        <p:spPr/>
+      </p:sp>
+    </p:spTree>
+  </p:cSld>
+  <p:clrMapOvr>
+    <a:masterClrMapping/>
+  </p:clrMapOvr>
+</p:notes>
+</file>
+
+<file path=ppt/notesSlides/notesSlide6.xml><?xml version="1.0" encoding="utf-8"?>
+<p:notes xmlns:a="http://schemas.openxmlformats.org/drawingml/2006/main" xmlns:p="http://schemas.openxmlformats.org/presentationml/2006/main" xmlns:r="http://schemas.openxmlformats.org/officeDocument/2006/relationships">
+  <p:cSld>
+    <p:spTree>
+      <p:nvGrpSpPr>
+        <p:cNvPr id="1" name=""/>
+        <p:cNvGrpSpPr/>
+        <p:nvPr/>
+      </p:nvGrpSpPr>
+      <p:grpSpPr>
+        <a:xfrm>
+          <a:off x="0" y="0"/>
+          <a:ext cx="0" cy="0"/>
+          <a:chOff x="0" y="0"/>
+          <a:chExt cx="0" cy="0"/>
+        </a:xfrm>
+      </p:grpSpPr>
+      <p:sp>
+        <p:nvSpPr>
+          <p:cNvPr id="2" name="Slide Image Placeholder 1"/>
+          <p:cNvSpPr>
+            <a:spLocks noGrp="1"/>
+          </p:cNvSpPr>
+          <p:nvPr>
+            <p:ph type="sldImg" idx="2"/>
+          </p:nvPr>
+        </p:nvSpPr>
+        <p:spPr/>
+      </p:sp>
+      <p:sp>
+        <p:nvSpPr>
+          <p:cNvPr id="3" name="Notes Placeholder 2"/>
+          <p:cNvSpPr>
+            <a:spLocks noGrp="1"/>
+          </p:cNvSpPr>
+          <p:nvPr>
+            <p:ph type="body" idx="3" sz="quarter"/>
+          </p:nvPr>
+        </p:nvSpPr>
+        <p:spPr/>
+        <p:txBody>
+          <a:bodyPr/>
+          <a:lstStyle/>
+          <a:p>
+            <a:r>
+              <a:t>Kernbefund des Falls – formal und sicherheitenseitig in Ordnung, scheitert aber an der § 18-Offenlegung. Nachzufordern: (1) Jahresabschluss Vor-Vorjahr, (2) aktuelle BWA, (3) aktualisierte Selbstauskunft.</a:t>
+            </a:r>
+          </a:p>
+        </p:txBody>
+      </p:sp>
+      <p:sp>
+        <p:nvSpPr>
+          <p:cNvPr id="4" name="Slide Number Placeholder 3"/>
+          <p:cNvSpPr>
+            <a:spLocks noGrp="1"/>
+          </p:cNvSpPr>
+          <p:nvPr>
+            <p:ph type="sldNum" idx="5" sz="quarter"/>
+          </p:nvPr>
+        </p:nvSpPr>
+        <p:spPr/>
+      </p:sp>
+    </p:spTree>
+  </p:cSld>
+  <p:clrMapOvr>
+    <a:masterClrMapping/>
+  </p:clrMapOvr>
+</p:notes>
+</file>
+
+<file path=ppt/notesSlides/notesSlide7.xml><?xml version="1.0" encoding="utf-8"?>
+<p:notes xmlns:a="http://schemas.openxmlformats.org/drawingml/2006/main" xmlns:p="http://schemas.openxmlformats.org/presentationml/2006/main" xmlns:r="http://schemas.openxmlformats.org/officeDocument/2006/relationships">
+  <p:cSld>
+    <p:spTree>
+      <p:nvGrpSpPr>
+        <p:cNvPr id="1" name=""/>
+        <p:cNvGrpSpPr/>
+        <p:nvPr/>
+      </p:nvGrpSpPr>
+      <p:grpSpPr>
+        <a:xfrm>
+          <a:off x="0" y="0"/>
+          <a:ext cx="0" cy="0"/>
+          <a:chOff x="0" y="0"/>
+          <a:chExt cx="0" cy="0"/>
+        </a:xfrm>
+      </p:grpSpPr>
+      <p:sp>
+        <p:nvSpPr>
+          <p:cNvPr id="2" name="Slide Image Placeholder 1"/>
+          <p:cNvSpPr>
+            <a:spLocks noGrp="1"/>
+          </p:cNvSpPr>
+          <p:nvPr>
+            <p:ph type="sldImg" idx="2"/>
+          </p:nvPr>
+        </p:nvSpPr>
+        <p:spPr/>
+      </p:sp>
+      <p:sp>
+        <p:nvSpPr>
+          <p:cNvPr id="3" name="Notes Placeholder 2"/>
+          <p:cNvSpPr>
+            <a:spLocks noGrp="1"/>
+          </p:cNvSpPr>
+          <p:nvPr>
+            <p:ph type="body" idx="3" sz="quarter"/>
+          </p:nvPr>
+        </p:nvSpPr>
+        <p:spPr/>
+        <p:txBody>
+          <a:bodyPr/>
+          <a:lstStyle/>
+          <a:p>
+            <a:r>
+              <a:t>AB-2 Musterlösung (Trainer-Version)</a:t>
+            </a:r>
+          </a:p>
+          <a:p>
+            <a:r>
+              <a:t>Vollständig/aktuell: Kreditantrag, Kreditbeschluss/Votum, Kreditvertrag, Sicherheiten/Grundbuch, HR-Auszug/KYC.</a:t>
+            </a:r>
+          </a:p>
+          <a:p>
+            <a:r>
+              <a:t>Veraltet: aktuelle BWA (7 Monate – sollte höchstens 3 Monate sein), Selbstauskunft GGF (3 Jahre alt). Fehlt: zweiter Jahresabschluss.</a:t>
+            </a:r>
+          </a:p>
+          <a:p>
+            <a:r>
+              <a:t>Trainer-Hinweis: Ziel ist das Prinzip formale Vollständigkeit ist nicht gleich ordnungsgemäße Akte, nicht das Auswendiglernen einer Liste.</a:t>
+            </a:r>
+          </a:p>
+        </p:txBody>
+      </p:sp>
+      <p:sp>
+        <p:nvSpPr>
+          <p:cNvPr id="4" name="Slide Number Placeholder 3"/>
+          <p:cNvSpPr>
+            <a:spLocks noGrp="1"/>
+          </p:cNvSpPr>
+          <p:nvPr>
+            <p:ph type="sldNum" idx="5" sz="quarter"/>
+          </p:nvPr>
+        </p:nvSpPr>
+        <p:spPr/>
+      </p:sp>
+    </p:spTree>
+  </p:cSld>
+  <p:clrMapOvr>
+    <a:masterClrMapping/>
+  </p:clrMapOvr>
+</p:notes>
+</file>
+
+<file path=ppt/notesSlides/notesSlide8.xml><?xml version="1.0" encoding="utf-8"?>
+<p:notes xmlns:a="http://schemas.openxmlformats.org/drawingml/2006/main" xmlns:p="http://schemas.openxmlformats.org/presentationml/2006/main" xmlns:r="http://schemas.openxmlformats.org/officeDocument/2006/relationships">
+  <p:cSld>
+    <p:spTree>
+      <p:nvGrpSpPr>
+        <p:cNvPr id="1" name=""/>
+        <p:cNvGrpSpPr/>
+        <p:nvPr/>
+      </p:nvGrpSpPr>
+      <p:grpSpPr>
+        <a:xfrm>
+          <a:off x="0" y="0"/>
+          <a:ext cx="0" cy="0"/>
+          <a:chOff x="0" y="0"/>
+          <a:chExt cx="0" cy="0"/>
+        </a:xfrm>
+      </p:grpSpPr>
+      <p:sp>
+        <p:nvSpPr>
+          <p:cNvPr id="2" name="Slide Image Placeholder 1"/>
+          <p:cNvSpPr>
+            <a:spLocks noGrp="1"/>
+          </p:cNvSpPr>
+          <p:nvPr>
+            <p:ph type="sldImg" idx="2"/>
+          </p:nvPr>
+        </p:nvSpPr>
+        <p:spPr/>
+      </p:sp>
+      <p:sp>
+        <p:nvSpPr>
+          <p:cNvPr id="3" name="Notes Placeholder 2"/>
+          <p:cNvSpPr>
+            <a:spLocks noGrp="1"/>
+          </p:cNvSpPr>
+          <p:nvPr>
+            <p:ph type="body" idx="3" sz="quarter"/>
+          </p:nvPr>
+        </p:nvSpPr>
+        <p:spPr/>
+        <p:txBody>
+          <a:bodyPr/>
+          <a:lstStyle/>
+          <a:p>
+            <a:r>
+              <a:t>Überleitung zum Transfer – die Checkliste AB-5 ist das Werkzeug für morgen früh.</a:t>
+            </a:r>
+          </a:p>
+        </p:txBody>
+      </p:sp>
+      <p:sp>
+        <p:nvSpPr>
+          <p:cNvPr id="4" name="Slide Number Placeholder 3"/>
+          <p:cNvSpPr>
+            <a:spLocks noGrp="1"/>
+          </p:cNvSpPr>
+          <p:nvPr>
+            <p:ph type="sldNum" idx="5" sz="quarter"/>
+          </p:nvPr>
+        </p:nvSpPr>
+        <p:spPr/>
+      </p:sp>
+    </p:spTree>
+  </p:cSld>
+  <p:clrMapOvr>
+    <a:masterClrMapping/>
+  </p:clrMapOvr>
+</p:notes>
+</file>
+
+<file path=ppt/notesSlides/notesSlide9.xml><?xml version="1.0" encoding="utf-8"?>
+<p:notes xmlns:a="http://schemas.openxmlformats.org/drawingml/2006/main" xmlns:p="http://schemas.openxmlformats.org/presentationml/2006/main" xmlns:r="http://schemas.openxmlformats.org/officeDocument/2006/relationships">
+  <p:cSld>
+    <p:spTree>
+      <p:nvGrpSpPr>
+        <p:cNvPr id="1" name=""/>
+        <p:cNvGrpSpPr/>
+        <p:nvPr/>
+      </p:nvGrpSpPr>
+      <p:grpSpPr>
+        <a:xfrm>
+          <a:off x="0" y="0"/>
+          <a:ext cx="0" cy="0"/>
+          <a:chOff x="0" y="0"/>
+          <a:chExt cx="0" cy="0"/>
+        </a:xfrm>
+      </p:grpSpPr>
+      <p:sp>
+        <p:nvSpPr>
+          <p:cNvPr id="2" name="Slide Image Placeholder 1"/>
+          <p:cNvSpPr>
+            <a:spLocks noGrp="1"/>
+          </p:cNvSpPr>
+          <p:nvPr>
+            <p:ph type="sldImg" idx="2"/>
+          </p:nvPr>
+        </p:nvSpPr>
+        <p:spPr/>
+      </p:sp>
+      <p:sp>
+        <p:nvSpPr>
+          <p:cNvPr id="3" name="Notes Placeholder 2"/>
+          <p:cNvSpPr>
+            <a:spLocks noGrp="1"/>
+          </p:cNvSpPr>
+          <p:nvPr>
+            <p:ph type="body" idx="3" sz="quarter"/>
+          </p:nvPr>
+        </p:nvSpPr>
+        <p:spPr/>
+        <p:txBody>
+          <a:bodyPr/>
+          <a:lstStyle/>
+          <a:p>
+            <a:r>
+              <a:t>Im Plenum Frage 1 oder 4 besprechen; Fragen 2 und 3 als schriftliche Aufgabe mitgeben (Fundament für VA02).</a:t>
             </a:r>
           </a:p>
         </p:txBody>
@@ -4385,6 +4668,2829 @@
 </p:sld>
 </file>
 
+<file path=ppt/slides/slide10.xml><?xml version="1.0" encoding="utf-8"?>
+<p:sld xmlns:a="http://schemas.openxmlformats.org/drawingml/2006/main" xmlns:p="http://schemas.openxmlformats.org/presentationml/2006/main" xmlns:r="http://schemas.openxmlformats.org/officeDocument/2006/relationships">
+  <p:cSld>
+    <p:spTree>
+      <p:nvGrpSpPr>
+        <p:cNvPr id="1" name=""/>
+        <p:cNvGrpSpPr/>
+        <p:nvPr/>
+      </p:nvGrpSpPr>
+      <p:grpSpPr/>
+      <p:sp>
+        <p:nvSpPr>
+          <p:cNvPr id="2" name="Rectangle 1"/>
+          <p:cNvSpPr/>
+          <p:nvPr/>
+        </p:nvSpPr>
+        <p:spPr>
+          <a:xfrm>
+            <a:off x="0" y="0"/>
+            <a:ext cx="12188952" cy="6858000"/>
+          </a:xfrm>
+          <a:prstGeom prst="rect">
+            <a:avLst/>
+          </a:prstGeom>
+          <a:solidFill>
+            <a:srgbClr val="FFFFFF"/>
+          </a:solidFill>
+          <a:ln>
+            <a:noFill/>
+          </a:ln>
+        </p:spPr>
+        <p:style>
+          <a:lnRef idx="1">
+            <a:schemeClr val="accent1"/>
+          </a:lnRef>
+          <a:fillRef idx="3">
+            <a:schemeClr val="accent1"/>
+          </a:fillRef>
+          <a:effectRef idx="2">
+            <a:schemeClr val="accent1"/>
+          </a:effectRef>
+          <a:fontRef idx="minor">
+            <a:schemeClr val="lt1"/>
+          </a:fontRef>
+        </p:style>
+        <p:txBody>
+          <a:bodyPr rtlCol="0" anchor="ctr"/>
+          <a:lstStyle/>
+          <a:p>
+            <a:pPr algn="ctr"/>
+          </a:p>
+        </p:txBody>
+      </p:sp>
+      <p:sp>
+        <p:nvSpPr>
+          <p:cNvPr id="3" name="Rectangle 2"/>
+          <p:cNvSpPr/>
+          <p:nvPr/>
+        </p:nvSpPr>
+        <p:spPr>
+          <a:xfrm>
+            <a:off x="0" y="0"/>
+            <a:ext cx="12188952" cy="50292"/>
+          </a:xfrm>
+          <a:prstGeom prst="rect">
+            <a:avLst/>
+          </a:prstGeom>
+          <a:solidFill>
+            <a:srgbClr val="1F2C56"/>
+          </a:solidFill>
+          <a:ln>
+            <a:noFill/>
+          </a:ln>
+        </p:spPr>
+        <p:style>
+          <a:lnRef idx="1">
+            <a:schemeClr val="accent1"/>
+          </a:lnRef>
+          <a:fillRef idx="3">
+            <a:schemeClr val="accent1"/>
+          </a:fillRef>
+          <a:effectRef idx="2">
+            <a:schemeClr val="accent1"/>
+          </a:effectRef>
+          <a:fontRef idx="minor">
+            <a:schemeClr val="lt1"/>
+          </a:fontRef>
+        </p:style>
+        <p:txBody>
+          <a:bodyPr rtlCol="0" anchor="ctr"/>
+          <a:lstStyle/>
+          <a:p>
+            <a:pPr algn="ctr"/>
+          </a:p>
+        </p:txBody>
+      </p:sp>
+      <p:sp>
+        <p:nvSpPr>
+          <p:cNvPr id="4" name="TextBox 3"/>
+          <p:cNvSpPr txBox="1"/>
+          <p:nvPr/>
+        </p:nvSpPr>
+        <p:spPr>
+          <a:xfrm>
+            <a:off x="685800" y="109728"/>
+            <a:ext cx="10817352" cy="228600"/>
+          </a:xfrm>
+          <a:prstGeom prst="rect">
+            <a:avLst/>
+          </a:prstGeom>
+          <a:noFill/>
+        </p:spPr>
+        <p:txBody>
+          <a:bodyPr wrap="none">
+            <a:spAutoFit/>
+          </a:bodyPr>
+          <a:lstStyle/>
+          <a:p>
+            <a:pPr algn="l"/>
+            <a:r>
+              <a:rPr sz="750">
+                <a:solidFill>
+                  <a:srgbClr val="78808C"/>
+                </a:solidFill>
+                <a:latin typeface="Consolas"/>
+              </a:rPr>
+              <a:t>VA01  ·  SCHAUBILD</a:t>
+            </a:r>
+          </a:p>
+        </p:txBody>
+      </p:sp>
+      <p:sp>
+        <p:nvSpPr>
+          <p:cNvPr id="5" name="TextBox 4"/>
+          <p:cNvSpPr txBox="1"/>
+          <p:nvPr/>
+        </p:nvSpPr>
+        <p:spPr>
+          <a:xfrm>
+            <a:off x="685800" y="502920"/>
+            <a:ext cx="10817352" cy="594360"/>
+          </a:xfrm>
+          <a:prstGeom prst="rect">
+            <a:avLst/>
+          </a:prstGeom>
+          <a:noFill/>
+        </p:spPr>
+        <p:txBody>
+          <a:bodyPr wrap="square">
+            <a:spAutoFit/>
+          </a:bodyPr>
+          <a:lstStyle/>
+          <a:p>
+            <a:pPr algn="l"/>
+            <a:r>
+              <a:rPr sz="2000" b="1" i="0">
+                <a:solidFill>
+                  <a:srgbClr val="1F2C56"/>
+                </a:solidFill>
+                <a:latin typeface="Arial"/>
+              </a:rPr>
+              <a:t>Funktionstrennung: Markt und Marktfolge</a:t>
+            </a:r>
+          </a:p>
+        </p:txBody>
+      </p:sp>
+      <p:sp>
+        <p:nvSpPr>
+          <p:cNvPr id="6" name="Rectangle 5"/>
+          <p:cNvSpPr/>
+          <p:nvPr/>
+        </p:nvSpPr>
+        <p:spPr>
+          <a:xfrm>
+            <a:off x="685800" y="1143000"/>
+            <a:ext cx="10817352" cy="25400"/>
+          </a:xfrm>
+          <a:prstGeom prst="rect">
+            <a:avLst/>
+          </a:prstGeom>
+          <a:solidFill>
+            <a:srgbClr val="D9C089"/>
+          </a:solidFill>
+          <a:ln>
+            <a:noFill/>
+          </a:ln>
+        </p:spPr>
+        <p:style>
+          <a:lnRef idx="1">
+            <a:schemeClr val="accent1"/>
+          </a:lnRef>
+          <a:fillRef idx="3">
+            <a:schemeClr val="accent1"/>
+          </a:fillRef>
+          <a:effectRef idx="2">
+            <a:schemeClr val="accent1"/>
+          </a:effectRef>
+          <a:fontRef idx="minor">
+            <a:schemeClr val="lt1"/>
+          </a:fontRef>
+        </p:style>
+        <p:txBody>
+          <a:bodyPr rtlCol="0" anchor="ctr"/>
+          <a:lstStyle/>
+          <a:p>
+            <a:pPr algn="ctr"/>
+          </a:p>
+        </p:txBody>
+      </p:sp>
+      <p:pic>
+        <p:nvPicPr>
+          <p:cNvPr id="7" name="Picture 6" descr="image.png"/>
+          <p:cNvPicPr>
+            <a:picLocks noChangeAspect="1"/>
+          </p:cNvPicPr>
+          <p:nvPr/>
+        </p:nvPicPr>
+        <p:blipFill>
+          <a:blip r:embed="rId2"/>
+          <a:stretch>
+            <a:fillRect/>
+          </a:stretch>
+        </p:blipFill>
+        <p:spPr>
+          <a:xfrm>
+            <a:off x="2009463" y="1325880"/>
+            <a:ext cx="8170026" cy="4937760"/>
+          </a:xfrm>
+          <a:prstGeom prst="rect">
+            <a:avLst/>
+          </a:prstGeom>
+        </p:spPr>
+      </p:pic>
+      <p:sp>
+        <p:nvSpPr>
+          <p:cNvPr id="8" name="Rectangle 7"/>
+          <p:cNvSpPr/>
+          <p:nvPr/>
+        </p:nvSpPr>
+        <p:spPr>
+          <a:xfrm>
+            <a:off x="0" y="6510528"/>
+            <a:ext cx="12188952" cy="347472"/>
+          </a:xfrm>
+          <a:prstGeom prst="rect">
+            <a:avLst/>
+          </a:prstGeom>
+          <a:solidFill>
+            <a:srgbClr val="0A1937"/>
+          </a:solidFill>
+          <a:ln>
+            <a:noFill/>
+          </a:ln>
+        </p:spPr>
+        <p:style>
+          <a:lnRef idx="1">
+            <a:schemeClr val="accent1"/>
+          </a:lnRef>
+          <a:fillRef idx="3">
+            <a:schemeClr val="accent1"/>
+          </a:fillRef>
+          <a:effectRef idx="2">
+            <a:schemeClr val="accent1"/>
+          </a:effectRef>
+          <a:fontRef idx="minor">
+            <a:schemeClr val="lt1"/>
+          </a:fontRef>
+        </p:style>
+        <p:txBody>
+          <a:bodyPr rtlCol="0" anchor="ctr"/>
+          <a:lstStyle/>
+          <a:p>
+            <a:pPr algn="ctr"/>
+          </a:p>
+        </p:txBody>
+      </p:sp>
+      <p:sp>
+        <p:nvSpPr>
+          <p:cNvPr id="9" name="TextBox 8"/>
+          <p:cNvSpPr txBox="1"/>
+          <p:nvPr/>
+        </p:nvSpPr>
+        <p:spPr>
+          <a:xfrm>
+            <a:off x="685800" y="6583680"/>
+            <a:ext cx="6490411" cy="256032"/>
+          </a:xfrm>
+          <a:prstGeom prst="rect">
+            <a:avLst/>
+          </a:prstGeom>
+          <a:noFill/>
+        </p:spPr>
+        <p:txBody>
+          <a:bodyPr wrap="none">
+            <a:spAutoFit/>
+          </a:bodyPr>
+          <a:lstStyle/>
+          <a:p>
+            <a:pPr algn="l"/>
+            <a:r>
+              <a:rPr sz="700">
+                <a:solidFill>
+                  <a:srgbClr val="A0B4D2"/>
+                </a:solidFill>
+                <a:latin typeface="Consolas"/>
+              </a:rPr>
+              <a:t>FKB Campus  ·  VA01</a:t>
+            </a:r>
+          </a:p>
+        </p:txBody>
+      </p:sp>
+      <p:sp>
+        <p:nvSpPr>
+          <p:cNvPr id="10" name="TextBox 9"/>
+          <p:cNvSpPr txBox="1"/>
+          <p:nvPr/>
+        </p:nvSpPr>
+        <p:spPr>
+          <a:xfrm>
+            <a:off x="7176211" y="6583680"/>
+            <a:ext cx="4326940" cy="256032"/>
+          </a:xfrm>
+          <a:prstGeom prst="rect">
+            <a:avLst/>
+          </a:prstGeom>
+          <a:noFill/>
+        </p:spPr>
+        <p:txBody>
+          <a:bodyPr wrap="none">
+            <a:spAutoFit/>
+          </a:bodyPr>
+          <a:lstStyle/>
+          <a:p>
+            <a:pPr algn="r"/>
+            <a:r>
+              <a:rPr sz="700">
+                <a:solidFill>
+                  <a:srgbClr val="A0B4D2"/>
+                </a:solidFill>
+                <a:latin typeface="Consolas"/>
+              </a:rPr>
+              <a:t>Schaubild</a:t>
+            </a:r>
+          </a:p>
+        </p:txBody>
+      </p:sp>
+    </p:spTree>
+  </p:cSld>
+  <p:clrMapOvr>
+    <a:masterClrMapping/>
+  </p:clrMapOvr>
+</p:sld>
+</file>
+
+<file path=ppt/slides/slide11.xml><?xml version="1.0" encoding="utf-8"?>
+<p:sld xmlns:a="http://schemas.openxmlformats.org/drawingml/2006/main" xmlns:p="http://schemas.openxmlformats.org/presentationml/2006/main" xmlns:r="http://schemas.openxmlformats.org/officeDocument/2006/relationships">
+  <p:cSld>
+    <p:spTree>
+      <p:nvGrpSpPr>
+        <p:cNvPr id="1" name=""/>
+        <p:cNvGrpSpPr/>
+        <p:nvPr/>
+      </p:nvGrpSpPr>
+      <p:grpSpPr/>
+      <p:sp>
+        <p:nvSpPr>
+          <p:cNvPr id="2" name="Rectangle 1"/>
+          <p:cNvSpPr/>
+          <p:nvPr/>
+        </p:nvSpPr>
+        <p:spPr>
+          <a:xfrm>
+            <a:off x="0" y="0"/>
+            <a:ext cx="12188952" cy="6858000"/>
+          </a:xfrm>
+          <a:prstGeom prst="rect">
+            <a:avLst/>
+          </a:prstGeom>
+          <a:solidFill>
+            <a:srgbClr val="1F2C56"/>
+          </a:solidFill>
+          <a:ln>
+            <a:noFill/>
+          </a:ln>
+        </p:spPr>
+        <p:style>
+          <a:lnRef idx="1">
+            <a:schemeClr val="accent1"/>
+          </a:lnRef>
+          <a:fillRef idx="3">
+            <a:schemeClr val="accent1"/>
+          </a:fillRef>
+          <a:effectRef idx="2">
+            <a:schemeClr val="accent1"/>
+          </a:effectRef>
+          <a:fontRef idx="minor">
+            <a:schemeClr val="lt1"/>
+          </a:fontRef>
+        </p:style>
+        <p:txBody>
+          <a:bodyPr rtlCol="0" anchor="ctr"/>
+          <a:lstStyle/>
+          <a:p>
+            <a:pPr algn="ctr"/>
+          </a:p>
+        </p:txBody>
+      </p:sp>
+      <p:sp>
+        <p:nvSpPr>
+          <p:cNvPr id="3" name="TextBox 2"/>
+          <p:cNvSpPr txBox="1"/>
+          <p:nvPr/>
+        </p:nvSpPr>
+        <p:spPr>
+          <a:xfrm>
+            <a:off x="685800" y="2377440"/>
+            <a:ext cx="10817352" cy="365760"/>
+          </a:xfrm>
+          <a:prstGeom prst="rect">
+            <a:avLst/>
+          </a:prstGeom>
+          <a:noFill/>
+        </p:spPr>
+        <p:txBody>
+          <a:bodyPr wrap="none">
+            <a:spAutoFit/>
+          </a:bodyPr>
+          <a:lstStyle/>
+          <a:p>
+            <a:pPr algn="l"/>
+            <a:r>
+              <a:rPr sz="1200">
+                <a:solidFill>
+                  <a:srgbClr val="D9C089"/>
+                </a:solidFill>
+                <a:latin typeface="Consolas"/>
+              </a:rPr>
+              <a:t>00:30–01:20</a:t>
+            </a:r>
+          </a:p>
+        </p:txBody>
+      </p:sp>
+      <p:sp>
+        <p:nvSpPr>
+          <p:cNvPr id="4" name="Rectangle 3"/>
+          <p:cNvSpPr/>
+          <p:nvPr/>
+        </p:nvSpPr>
+        <p:spPr>
+          <a:xfrm>
+            <a:off x="685800" y="2788920"/>
+            <a:ext cx="548640" cy="38100"/>
+          </a:xfrm>
+          <a:prstGeom prst="rect">
+            <a:avLst/>
+          </a:prstGeom>
+          <a:solidFill>
+            <a:srgbClr val="D9C089"/>
+          </a:solidFill>
+          <a:ln>
+            <a:noFill/>
+          </a:ln>
+        </p:spPr>
+        <p:style>
+          <a:lnRef idx="1">
+            <a:schemeClr val="accent1"/>
+          </a:lnRef>
+          <a:fillRef idx="3">
+            <a:schemeClr val="accent1"/>
+          </a:fillRef>
+          <a:effectRef idx="2">
+            <a:schemeClr val="accent1"/>
+          </a:effectRef>
+          <a:fontRef idx="minor">
+            <a:schemeClr val="lt1"/>
+          </a:fontRef>
+        </p:style>
+        <p:txBody>
+          <a:bodyPr rtlCol="0" anchor="ctr"/>
+          <a:lstStyle/>
+          <a:p>
+            <a:pPr algn="ctr"/>
+          </a:p>
+        </p:txBody>
+      </p:sp>
+      <p:sp>
+        <p:nvSpPr>
+          <p:cNvPr id="5" name="TextBox 4"/>
+          <p:cNvSpPr txBox="1"/>
+          <p:nvPr/>
+        </p:nvSpPr>
+        <p:spPr>
+          <a:xfrm>
+            <a:off x="685800" y="3017520"/>
+            <a:ext cx="10817352" cy="1463040"/>
+          </a:xfrm>
+          <a:prstGeom prst="rect">
+            <a:avLst/>
+          </a:prstGeom>
+          <a:noFill/>
+        </p:spPr>
+        <p:txBody>
+          <a:bodyPr wrap="square">
+            <a:spAutoFit/>
+          </a:bodyPr>
+          <a:lstStyle/>
+          <a:p>
+            <a:pPr algn="l"/>
+            <a:r>
+              <a:rPr sz="4000" b="1" i="0">
+                <a:solidFill>
+                  <a:srgbClr val="FFFFFF"/>
+                </a:solidFill>
+                <a:latin typeface="Arial"/>
+              </a:rPr>
+              <a:t>Fallübergabe &amp; Fallarbeit</a:t>
+            </a:r>
+          </a:p>
+        </p:txBody>
+      </p:sp>
+      <p:sp>
+        <p:nvSpPr>
+          <p:cNvPr id="6" name="TextBox 5"/>
+          <p:cNvSpPr txBox="1"/>
+          <p:nvPr/>
+        </p:nvSpPr>
+        <p:spPr>
+          <a:xfrm>
+            <a:off x="685800" y="4480560"/>
+            <a:ext cx="8653881" cy="1280160"/>
+          </a:xfrm>
+          <a:prstGeom prst="rect">
+            <a:avLst/>
+          </a:prstGeom>
+          <a:noFill/>
+        </p:spPr>
+        <p:txBody>
+          <a:bodyPr wrap="square">
+            <a:spAutoFit/>
+          </a:bodyPr>
+          <a:lstStyle/>
+          <a:p>
+            <a:pPr algn="l"/>
+            <a:r>
+              <a:rPr sz="1600" b="0" i="0">
+                <a:solidFill>
+                  <a:srgbClr val="C8D2E6"/>
+                </a:solidFill>
+                <a:latin typeface="Arial"/>
+              </a:rPr>
+              <a:t>Ist die Akte der Holzbau Musterregion GmbH auszahlungsreif?</a:t>
+            </a:r>
+          </a:p>
+        </p:txBody>
+      </p:sp>
+      <p:sp>
+        <p:nvSpPr>
+          <p:cNvPr id="7" name="TextBox 6"/>
+          <p:cNvSpPr txBox="1"/>
+          <p:nvPr/>
+        </p:nvSpPr>
+        <p:spPr>
+          <a:xfrm>
+            <a:off x="685800" y="6355080"/>
+            <a:ext cx="10817352" cy="274320"/>
+          </a:xfrm>
+          <a:prstGeom prst="rect">
+            <a:avLst/>
+          </a:prstGeom>
+          <a:noFill/>
+        </p:spPr>
+        <p:txBody>
+          <a:bodyPr wrap="none">
+            <a:spAutoFit/>
+          </a:bodyPr>
+          <a:lstStyle/>
+          <a:p>
+            <a:pPr algn="l"/>
+            <a:r>
+              <a:rPr sz="700">
+                <a:solidFill>
+                  <a:srgbClr val="8CA0C3"/>
+                </a:solidFill>
+                <a:latin typeface="Consolas"/>
+              </a:rPr>
+              <a:t>FKB Campus  ·  VA01</a:t>
+            </a:r>
+          </a:p>
+        </p:txBody>
+      </p:sp>
+    </p:spTree>
+  </p:cSld>
+  <p:clrMapOvr>
+    <a:masterClrMapping/>
+  </p:clrMapOvr>
+</p:sld>
+</file>
+
+<file path=ppt/slides/slide12.xml><?xml version="1.0" encoding="utf-8"?>
+<p:sld xmlns:a="http://schemas.openxmlformats.org/drawingml/2006/main" xmlns:p="http://schemas.openxmlformats.org/presentationml/2006/main" xmlns:r="http://schemas.openxmlformats.org/officeDocument/2006/relationships">
+  <p:cSld>
+    <p:spTree>
+      <p:nvGrpSpPr>
+        <p:cNvPr id="1" name=""/>
+        <p:cNvGrpSpPr/>
+        <p:nvPr/>
+      </p:nvGrpSpPr>
+      <p:grpSpPr/>
+      <p:sp>
+        <p:nvSpPr>
+          <p:cNvPr id="2" name="Rectangle 1"/>
+          <p:cNvSpPr/>
+          <p:nvPr/>
+        </p:nvSpPr>
+        <p:spPr>
+          <a:xfrm>
+            <a:off x="0" y="0"/>
+            <a:ext cx="12188952" cy="6858000"/>
+          </a:xfrm>
+          <a:prstGeom prst="rect">
+            <a:avLst/>
+          </a:prstGeom>
+          <a:solidFill>
+            <a:srgbClr val="EDEDF3"/>
+          </a:solidFill>
+          <a:ln>
+            <a:noFill/>
+          </a:ln>
+        </p:spPr>
+        <p:style>
+          <a:lnRef idx="1">
+            <a:schemeClr val="accent1"/>
+          </a:lnRef>
+          <a:fillRef idx="3">
+            <a:schemeClr val="accent1"/>
+          </a:fillRef>
+          <a:effectRef idx="2">
+            <a:schemeClr val="accent1"/>
+          </a:effectRef>
+          <a:fontRef idx="minor">
+            <a:schemeClr val="lt1"/>
+          </a:fontRef>
+        </p:style>
+        <p:txBody>
+          <a:bodyPr rtlCol="0" anchor="ctr"/>
+          <a:lstStyle/>
+          <a:p>
+            <a:pPr algn="ctr"/>
+          </a:p>
+        </p:txBody>
+      </p:sp>
+      <p:sp>
+        <p:nvSpPr>
+          <p:cNvPr id="3" name="Rectangle 2"/>
+          <p:cNvSpPr/>
+          <p:nvPr/>
+        </p:nvSpPr>
+        <p:spPr>
+          <a:xfrm>
+            <a:off x="0" y="0"/>
+            <a:ext cx="12188952" cy="50292"/>
+          </a:xfrm>
+          <a:prstGeom prst="rect">
+            <a:avLst/>
+          </a:prstGeom>
+          <a:solidFill>
+            <a:srgbClr val="1F2C56"/>
+          </a:solidFill>
+          <a:ln>
+            <a:noFill/>
+          </a:ln>
+        </p:spPr>
+        <p:style>
+          <a:lnRef idx="1">
+            <a:schemeClr val="accent1"/>
+          </a:lnRef>
+          <a:fillRef idx="3">
+            <a:schemeClr val="accent1"/>
+          </a:fillRef>
+          <a:effectRef idx="2">
+            <a:schemeClr val="accent1"/>
+          </a:effectRef>
+          <a:fontRef idx="minor">
+            <a:schemeClr val="lt1"/>
+          </a:fontRef>
+        </p:style>
+        <p:txBody>
+          <a:bodyPr rtlCol="0" anchor="ctr"/>
+          <a:lstStyle/>
+          <a:p>
+            <a:pPr algn="ctr"/>
+          </a:p>
+        </p:txBody>
+      </p:sp>
+      <p:sp>
+        <p:nvSpPr>
+          <p:cNvPr id="4" name="TextBox 3"/>
+          <p:cNvSpPr txBox="1"/>
+          <p:nvPr/>
+        </p:nvSpPr>
+        <p:spPr>
+          <a:xfrm>
+            <a:off x="685800" y="109728"/>
+            <a:ext cx="10817352" cy="228600"/>
+          </a:xfrm>
+          <a:prstGeom prst="rect">
+            <a:avLst/>
+          </a:prstGeom>
+          <a:noFill/>
+        </p:spPr>
+        <p:txBody>
+          <a:bodyPr wrap="none">
+            <a:spAutoFit/>
+          </a:bodyPr>
+          <a:lstStyle/>
+          <a:p>
+            <a:pPr algn="l"/>
+            <a:r>
+              <a:rPr sz="750">
+                <a:solidFill>
+                  <a:srgbClr val="78808C"/>
+                </a:solidFill>
+                <a:latin typeface="Consolas"/>
+              </a:rPr>
+              <a:t>VA01  ·  INHALT</a:t>
+            </a:r>
+          </a:p>
+        </p:txBody>
+      </p:sp>
+      <p:sp>
+        <p:nvSpPr>
+          <p:cNvPr id="5" name="Rectangle 4"/>
+          <p:cNvSpPr/>
+          <p:nvPr/>
+        </p:nvSpPr>
+        <p:spPr>
+          <a:xfrm>
+            <a:off x="0" y="1234440"/>
+            <a:ext cx="12188952" cy="12700"/>
+          </a:xfrm>
+          <a:prstGeom prst="rect">
+            <a:avLst/>
+          </a:prstGeom>
+          <a:solidFill>
+            <a:srgbClr val="D8DFE4"/>
+          </a:solidFill>
+          <a:ln>
+            <a:noFill/>
+          </a:ln>
+        </p:spPr>
+        <p:style>
+          <a:lnRef idx="1">
+            <a:schemeClr val="accent1"/>
+          </a:lnRef>
+          <a:fillRef idx="3">
+            <a:schemeClr val="accent1"/>
+          </a:fillRef>
+          <a:effectRef idx="2">
+            <a:schemeClr val="accent1"/>
+          </a:effectRef>
+          <a:fontRef idx="minor">
+            <a:schemeClr val="lt1"/>
+          </a:fontRef>
+        </p:style>
+        <p:txBody>
+          <a:bodyPr rtlCol="0" anchor="ctr"/>
+          <a:lstStyle/>
+          <a:p>
+            <a:pPr algn="ctr"/>
+          </a:p>
+        </p:txBody>
+      </p:sp>
+      <p:sp>
+        <p:nvSpPr>
+          <p:cNvPr id="6" name="Rectangle 5"/>
+          <p:cNvSpPr/>
+          <p:nvPr/>
+        </p:nvSpPr>
+        <p:spPr>
+          <a:xfrm>
+            <a:off x="685800" y="502920"/>
+            <a:ext cx="36576" cy="658368"/>
+          </a:xfrm>
+          <a:prstGeom prst="rect">
+            <a:avLst/>
+          </a:prstGeom>
+          <a:solidFill>
+            <a:srgbClr val="D9C089"/>
+          </a:solidFill>
+          <a:ln>
+            <a:noFill/>
+          </a:ln>
+        </p:spPr>
+        <p:style>
+          <a:lnRef idx="1">
+            <a:schemeClr val="accent1"/>
+          </a:lnRef>
+          <a:fillRef idx="3">
+            <a:schemeClr val="accent1"/>
+          </a:fillRef>
+          <a:effectRef idx="2">
+            <a:schemeClr val="accent1"/>
+          </a:effectRef>
+          <a:fontRef idx="minor">
+            <a:schemeClr val="lt1"/>
+          </a:fontRef>
+        </p:style>
+        <p:txBody>
+          <a:bodyPr rtlCol="0" anchor="ctr"/>
+          <a:lstStyle/>
+          <a:p>
+            <a:pPr algn="ctr"/>
+          </a:p>
+        </p:txBody>
+      </p:sp>
+      <p:sp>
+        <p:nvSpPr>
+          <p:cNvPr id="7" name="TextBox 6"/>
+          <p:cNvSpPr txBox="1"/>
+          <p:nvPr/>
+        </p:nvSpPr>
+        <p:spPr>
+          <a:xfrm>
+            <a:off x="813816" y="502920"/>
+            <a:ext cx="10634472" cy="685800"/>
+          </a:xfrm>
+          <a:prstGeom prst="rect">
+            <a:avLst/>
+          </a:prstGeom>
+          <a:noFill/>
+        </p:spPr>
+        <p:txBody>
+          <a:bodyPr wrap="square">
+            <a:spAutoFit/>
+          </a:bodyPr>
+          <a:lstStyle/>
+          <a:p>
+            <a:pPr algn="l"/>
+            <a:r>
+              <a:rPr sz="2400" b="1" i="0">
+                <a:solidFill>
+                  <a:srgbClr val="1F2C56"/>
+                </a:solidFill>
+                <a:latin typeface="Arial"/>
+              </a:rPr>
+              <a:t>Praxisfall: Holzbau Musterregion GmbH</a:t>
+            </a:r>
+          </a:p>
+        </p:txBody>
+      </p:sp>
+      <p:sp>
+        <p:nvSpPr>
+          <p:cNvPr id="8" name="TextBox 7"/>
+          <p:cNvSpPr txBox="1"/>
+          <p:nvPr/>
+        </p:nvSpPr>
+        <p:spPr>
+          <a:xfrm>
+            <a:off x="685800" y="1417320"/>
+            <a:ext cx="10817352" cy="4892040"/>
+          </a:xfrm>
+          <a:prstGeom prst="rect">
+            <a:avLst/>
+          </a:prstGeom>
+          <a:noFill/>
+        </p:spPr>
+        <p:txBody>
+          <a:bodyPr wrap="square" anchor="ctr">
+            <a:spAutoFit/>
+          </a:bodyPr>
+          <a:lstStyle/>
+          <a:p>
+            <a:pPr>
+              <a:spcBef>
+                <a:spcPts val="1000"/>
+              </a:spcBef>
+              <a:spcAft>
+                <a:spcPts val="200"/>
+              </a:spcAft>
+            </a:pPr>
+            <a:r>
+              <a:rPr sz="800" b="1">
+                <a:solidFill>
+                  <a:srgbClr val="78808C"/>
+                </a:solidFill>
+                <a:latin typeface="Consolas"/>
+              </a:rPr>
+              <a:t>DER FALL</a:t>
+            </a:r>
+          </a:p>
+          <a:p>
+            <a:pPr marL="190500" indent="-190500">
+              <a:spcBef>
+                <a:spcPts val="400"/>
+              </a:spcBef>
+              <a:spcAft>
+                <a:spcPts val="200"/>
+              </a:spcAft>
+            </a:pPr>
+            <a:r>
+              <a:rPr sz="1300">
+                <a:solidFill>
+                  <a:srgbClr val="3D5466"/>
+                </a:solidFill>
+                <a:latin typeface="Arial"/>
+              </a:rPr>
+              <a:t>▸  Zimmerei- und Holzbaubetrieb, 18 Mitarbeiter, Hausbank VR-Bank Musterregion eG.</a:t>
+            </a:r>
+          </a:p>
+          <a:p>
+            <a:pPr marL="190500" indent="-190500">
+              <a:spcBef>
+                <a:spcPts val="400"/>
+              </a:spcBef>
+              <a:spcAft>
+                <a:spcPts val="200"/>
+              </a:spcAft>
+            </a:pPr>
+            <a:r>
+              <a:rPr sz="1300">
+                <a:solidFill>
+                  <a:srgbClr val="3D5466"/>
+                </a:solidFill>
+                <a:latin typeface="Arial"/>
+              </a:rPr>
+              <a:t>▸  Investitionskredit 900 TEUR (Abbundanlage und Hallenerweiterung) – die Auszahlung steht kurz bevor.</a:t>
+            </a:r>
+          </a:p>
+          <a:p>
+            <a:pPr>
+              <a:spcBef>
+                <a:spcPts val="1000"/>
+              </a:spcBef>
+              <a:spcAft>
+                <a:spcPts val="200"/>
+              </a:spcAft>
+            </a:pPr>
+            <a:r>
+              <a:rPr sz="800" b="1">
+                <a:solidFill>
+                  <a:srgbClr val="78808C"/>
+                </a:solidFill>
+                <a:latin typeface="Consolas"/>
+              </a:rPr>
+              <a:t>IHRE AUFGABE</a:t>
+            </a:r>
+          </a:p>
+          <a:p>
+            <a:pPr marL="190500" indent="-190500">
+              <a:spcBef>
+                <a:spcPts val="400"/>
+              </a:spcBef>
+              <a:spcAft>
+                <a:spcPts val="200"/>
+              </a:spcAft>
+            </a:pPr>
+            <a:r>
+              <a:rPr sz="1300">
+                <a:solidFill>
+                  <a:srgbClr val="3D5466"/>
+                </a:solidFill>
+                <a:latin typeface="Arial"/>
+              </a:rPr>
+              <a:t>▸  Die Kreditakte liegt Ihnen zur abschließenden Bearbeitung vor. Prüfen Sie vor der Auszahlungsfreigabe die Vollständigkeit.</a:t>
+            </a:r>
+          </a:p>
+        </p:txBody>
+      </p:sp>
+      <p:sp>
+        <p:nvSpPr>
+          <p:cNvPr id="9" name="Rectangle 8"/>
+          <p:cNvSpPr/>
+          <p:nvPr/>
+        </p:nvSpPr>
+        <p:spPr>
+          <a:xfrm>
+            <a:off x="0" y="6510528"/>
+            <a:ext cx="12188952" cy="347472"/>
+          </a:xfrm>
+          <a:prstGeom prst="rect">
+            <a:avLst/>
+          </a:prstGeom>
+          <a:solidFill>
+            <a:srgbClr val="0A1937"/>
+          </a:solidFill>
+          <a:ln>
+            <a:noFill/>
+          </a:ln>
+        </p:spPr>
+        <p:style>
+          <a:lnRef idx="1">
+            <a:schemeClr val="accent1"/>
+          </a:lnRef>
+          <a:fillRef idx="3">
+            <a:schemeClr val="accent1"/>
+          </a:fillRef>
+          <a:effectRef idx="2">
+            <a:schemeClr val="accent1"/>
+          </a:effectRef>
+          <a:fontRef idx="minor">
+            <a:schemeClr val="lt1"/>
+          </a:fontRef>
+        </p:style>
+        <p:txBody>
+          <a:bodyPr rtlCol="0" anchor="ctr"/>
+          <a:lstStyle/>
+          <a:p>
+            <a:pPr algn="ctr"/>
+          </a:p>
+        </p:txBody>
+      </p:sp>
+      <p:sp>
+        <p:nvSpPr>
+          <p:cNvPr id="10" name="TextBox 9"/>
+          <p:cNvSpPr txBox="1"/>
+          <p:nvPr/>
+        </p:nvSpPr>
+        <p:spPr>
+          <a:xfrm>
+            <a:off x="685800" y="6583680"/>
+            <a:ext cx="6490411" cy="256032"/>
+          </a:xfrm>
+          <a:prstGeom prst="rect">
+            <a:avLst/>
+          </a:prstGeom>
+          <a:noFill/>
+        </p:spPr>
+        <p:txBody>
+          <a:bodyPr wrap="none">
+            <a:spAutoFit/>
+          </a:bodyPr>
+          <a:lstStyle/>
+          <a:p>
+            <a:pPr algn="l"/>
+            <a:r>
+              <a:rPr sz="700">
+                <a:solidFill>
+                  <a:srgbClr val="A0B4D2"/>
+                </a:solidFill>
+                <a:latin typeface="Consolas"/>
+              </a:rPr>
+              <a:t>FKB Campus  ·  VA01</a:t>
+            </a:r>
+          </a:p>
+        </p:txBody>
+      </p:sp>
+    </p:spTree>
+  </p:cSld>
+  <p:clrMapOvr>
+    <a:masterClrMapping/>
+  </p:clrMapOvr>
+</p:sld>
+</file>
+
+<file path=ppt/slides/slide13.xml><?xml version="1.0" encoding="utf-8"?>
+<p:sld xmlns:a="http://schemas.openxmlformats.org/drawingml/2006/main" xmlns:p="http://schemas.openxmlformats.org/presentationml/2006/main" xmlns:r="http://schemas.openxmlformats.org/officeDocument/2006/relationships">
+  <p:cSld>
+    <p:spTree>
+      <p:nvGrpSpPr>
+        <p:cNvPr id="1" name=""/>
+        <p:cNvGrpSpPr/>
+        <p:nvPr/>
+      </p:nvGrpSpPr>
+      <p:grpSpPr/>
+      <p:sp>
+        <p:nvSpPr>
+          <p:cNvPr id="2" name="Rectangle 1"/>
+          <p:cNvSpPr/>
+          <p:nvPr/>
+        </p:nvSpPr>
+        <p:spPr>
+          <a:xfrm>
+            <a:off x="0" y="0"/>
+            <a:ext cx="12188952" cy="6858000"/>
+          </a:xfrm>
+          <a:prstGeom prst="rect">
+            <a:avLst/>
+          </a:prstGeom>
+          <a:solidFill>
+            <a:srgbClr val="EDEDF3"/>
+          </a:solidFill>
+          <a:ln>
+            <a:noFill/>
+          </a:ln>
+        </p:spPr>
+        <p:style>
+          <a:lnRef idx="1">
+            <a:schemeClr val="accent1"/>
+          </a:lnRef>
+          <a:fillRef idx="3">
+            <a:schemeClr val="accent1"/>
+          </a:fillRef>
+          <a:effectRef idx="2">
+            <a:schemeClr val="accent1"/>
+          </a:effectRef>
+          <a:fontRef idx="minor">
+            <a:schemeClr val="lt1"/>
+          </a:fontRef>
+        </p:style>
+        <p:txBody>
+          <a:bodyPr rtlCol="0" anchor="ctr"/>
+          <a:lstStyle/>
+          <a:p>
+            <a:pPr algn="ctr"/>
+          </a:p>
+        </p:txBody>
+      </p:sp>
+      <p:sp>
+        <p:nvSpPr>
+          <p:cNvPr id="3" name="Rectangle 2"/>
+          <p:cNvSpPr/>
+          <p:nvPr/>
+        </p:nvSpPr>
+        <p:spPr>
+          <a:xfrm>
+            <a:off x="0" y="0"/>
+            <a:ext cx="12188952" cy="50292"/>
+          </a:xfrm>
+          <a:prstGeom prst="rect">
+            <a:avLst/>
+          </a:prstGeom>
+          <a:solidFill>
+            <a:srgbClr val="1F2C56"/>
+          </a:solidFill>
+          <a:ln>
+            <a:noFill/>
+          </a:ln>
+        </p:spPr>
+        <p:style>
+          <a:lnRef idx="1">
+            <a:schemeClr val="accent1"/>
+          </a:lnRef>
+          <a:fillRef idx="3">
+            <a:schemeClr val="accent1"/>
+          </a:fillRef>
+          <a:effectRef idx="2">
+            <a:schemeClr val="accent1"/>
+          </a:effectRef>
+          <a:fontRef idx="minor">
+            <a:schemeClr val="lt1"/>
+          </a:fontRef>
+        </p:style>
+        <p:txBody>
+          <a:bodyPr rtlCol="0" anchor="ctr"/>
+          <a:lstStyle/>
+          <a:p>
+            <a:pPr algn="ctr"/>
+          </a:p>
+        </p:txBody>
+      </p:sp>
+      <p:sp>
+        <p:nvSpPr>
+          <p:cNvPr id="4" name="TextBox 3"/>
+          <p:cNvSpPr txBox="1"/>
+          <p:nvPr/>
+        </p:nvSpPr>
+        <p:spPr>
+          <a:xfrm>
+            <a:off x="685800" y="109728"/>
+            <a:ext cx="10817352" cy="228600"/>
+          </a:xfrm>
+          <a:prstGeom prst="rect">
+            <a:avLst/>
+          </a:prstGeom>
+          <a:noFill/>
+        </p:spPr>
+        <p:txBody>
+          <a:bodyPr wrap="none">
+            <a:spAutoFit/>
+          </a:bodyPr>
+          <a:lstStyle/>
+          <a:p>
+            <a:pPr algn="l"/>
+            <a:r>
+              <a:rPr sz="750">
+                <a:solidFill>
+                  <a:srgbClr val="78808C"/>
+                </a:solidFill>
+                <a:latin typeface="Consolas"/>
+              </a:rPr>
+              <a:t>VA01  ·  INHALT</a:t>
+            </a:r>
+          </a:p>
+        </p:txBody>
+      </p:sp>
+      <p:sp>
+        <p:nvSpPr>
+          <p:cNvPr id="5" name="Rectangle 4"/>
+          <p:cNvSpPr/>
+          <p:nvPr/>
+        </p:nvSpPr>
+        <p:spPr>
+          <a:xfrm>
+            <a:off x="0" y="1234440"/>
+            <a:ext cx="12188952" cy="12700"/>
+          </a:xfrm>
+          <a:prstGeom prst="rect">
+            <a:avLst/>
+          </a:prstGeom>
+          <a:solidFill>
+            <a:srgbClr val="D8DFE4"/>
+          </a:solidFill>
+          <a:ln>
+            <a:noFill/>
+          </a:ln>
+        </p:spPr>
+        <p:style>
+          <a:lnRef idx="1">
+            <a:schemeClr val="accent1"/>
+          </a:lnRef>
+          <a:fillRef idx="3">
+            <a:schemeClr val="accent1"/>
+          </a:fillRef>
+          <a:effectRef idx="2">
+            <a:schemeClr val="accent1"/>
+          </a:effectRef>
+          <a:fontRef idx="minor">
+            <a:schemeClr val="lt1"/>
+          </a:fontRef>
+        </p:style>
+        <p:txBody>
+          <a:bodyPr rtlCol="0" anchor="ctr"/>
+          <a:lstStyle/>
+          <a:p>
+            <a:pPr algn="ctr"/>
+          </a:p>
+        </p:txBody>
+      </p:sp>
+      <p:sp>
+        <p:nvSpPr>
+          <p:cNvPr id="6" name="Rectangle 5"/>
+          <p:cNvSpPr/>
+          <p:nvPr/>
+        </p:nvSpPr>
+        <p:spPr>
+          <a:xfrm>
+            <a:off x="685800" y="502920"/>
+            <a:ext cx="36576" cy="658368"/>
+          </a:xfrm>
+          <a:prstGeom prst="rect">
+            <a:avLst/>
+          </a:prstGeom>
+          <a:solidFill>
+            <a:srgbClr val="D9C089"/>
+          </a:solidFill>
+          <a:ln>
+            <a:noFill/>
+          </a:ln>
+        </p:spPr>
+        <p:style>
+          <a:lnRef idx="1">
+            <a:schemeClr val="accent1"/>
+          </a:lnRef>
+          <a:fillRef idx="3">
+            <a:schemeClr val="accent1"/>
+          </a:fillRef>
+          <a:effectRef idx="2">
+            <a:schemeClr val="accent1"/>
+          </a:effectRef>
+          <a:fontRef idx="minor">
+            <a:schemeClr val="lt1"/>
+          </a:fontRef>
+        </p:style>
+        <p:txBody>
+          <a:bodyPr rtlCol="0" anchor="ctr"/>
+          <a:lstStyle/>
+          <a:p>
+            <a:pPr algn="ctr"/>
+          </a:p>
+        </p:txBody>
+      </p:sp>
+      <p:sp>
+        <p:nvSpPr>
+          <p:cNvPr id="7" name="TextBox 6"/>
+          <p:cNvSpPr txBox="1"/>
+          <p:nvPr/>
+        </p:nvSpPr>
+        <p:spPr>
+          <a:xfrm>
+            <a:off x="813816" y="502920"/>
+            <a:ext cx="10634472" cy="685800"/>
+          </a:xfrm>
+          <a:prstGeom prst="rect">
+            <a:avLst/>
+          </a:prstGeom>
+          <a:noFill/>
+        </p:spPr>
+        <p:txBody>
+          <a:bodyPr wrap="square">
+            <a:spAutoFit/>
+          </a:bodyPr>
+          <a:lstStyle/>
+          <a:p>
+            <a:pPr algn="l"/>
+            <a:r>
+              <a:rPr sz="2400" b="1" i="0">
+                <a:solidFill>
+                  <a:srgbClr val="1F2C56"/>
+                </a:solidFill>
+                <a:latin typeface="Arial"/>
+              </a:rPr>
+              <a:t>Handlungsempfehlung: von der Lücke zur Handlung</a:t>
+            </a:r>
+          </a:p>
+        </p:txBody>
+      </p:sp>
+      <p:sp>
+        <p:nvSpPr>
+          <p:cNvPr id="8" name="TextBox 7"/>
+          <p:cNvSpPr txBox="1"/>
+          <p:nvPr/>
+        </p:nvSpPr>
+        <p:spPr>
+          <a:xfrm>
+            <a:off x="685800" y="1417320"/>
+            <a:ext cx="10817352" cy="4892040"/>
+          </a:xfrm>
+          <a:prstGeom prst="rect">
+            <a:avLst/>
+          </a:prstGeom>
+          <a:noFill/>
+        </p:spPr>
+        <p:txBody>
+          <a:bodyPr wrap="square" anchor="ctr">
+            <a:spAutoFit/>
+          </a:bodyPr>
+          <a:lstStyle/>
+          <a:p>
+            <a:pPr marL="177800" indent="-177800">
+              <a:spcBef>
+                <a:spcPts val="600"/>
+              </a:spcBef>
+              <a:spcAft>
+                <a:spcPts val="200"/>
+              </a:spcAft>
+            </a:pPr>
+            <a:r>
+              <a:rPr sz="1200" i="1">
+                <a:solidFill>
+                  <a:srgbClr val="3D5466"/>
+                </a:solidFill>
+                <a:latin typeface="Arial"/>
+              </a:rPr>
+              <a:t>→  Wenn aktuelle BWA älter als drei Monate — dann BWA beim Kunden bzw. Steuerberater nachfordern und Wiedervorlage setzen.</a:t>
+            </a:r>
+          </a:p>
+          <a:p>
+            <a:pPr marL="177800" indent="-177800">
+              <a:spcBef>
+                <a:spcPts val="600"/>
+              </a:spcBef>
+              <a:spcAft>
+                <a:spcPts val="200"/>
+              </a:spcAft>
+            </a:pPr>
+            <a:r>
+              <a:rPr sz="1200" i="1">
+                <a:solidFill>
+                  <a:srgbClr val="3D5466"/>
+                </a:solidFill>
+                <a:latin typeface="Arial"/>
+              </a:rPr>
+              <a:t>→  Wenn Offenlegungsunterlagen nach § 18 KWG unvollständig — dann vor Auszahlung die vollständige Offenlegung einholen und die Marktfolge informieren.</a:t>
+            </a:r>
+          </a:p>
+          <a:p>
+            <a:pPr marL="177800" indent="-177800">
+              <a:spcBef>
+                <a:spcPts val="600"/>
+              </a:spcBef>
+              <a:spcAft>
+                <a:spcPts val="200"/>
+              </a:spcAft>
+            </a:pPr>
+            <a:r>
+              <a:rPr sz="1200" i="1">
+                <a:solidFill>
+                  <a:srgbClr val="3D5466"/>
+                </a:solidFill>
+                <a:latin typeface="Arial"/>
+              </a:rPr>
+              <a:t>→  Wenn Selbstauskunft des Gesellschafter-GF veraltet — dann aktualisierte Selbstauskunft anfordern und Eingang dokumentieren.</a:t>
+            </a:r>
+          </a:p>
+        </p:txBody>
+      </p:sp>
+      <p:sp>
+        <p:nvSpPr>
+          <p:cNvPr id="9" name="Rectangle 8"/>
+          <p:cNvSpPr/>
+          <p:nvPr/>
+        </p:nvSpPr>
+        <p:spPr>
+          <a:xfrm>
+            <a:off x="0" y="6510528"/>
+            <a:ext cx="12188952" cy="347472"/>
+          </a:xfrm>
+          <a:prstGeom prst="rect">
+            <a:avLst/>
+          </a:prstGeom>
+          <a:solidFill>
+            <a:srgbClr val="0A1937"/>
+          </a:solidFill>
+          <a:ln>
+            <a:noFill/>
+          </a:ln>
+        </p:spPr>
+        <p:style>
+          <a:lnRef idx="1">
+            <a:schemeClr val="accent1"/>
+          </a:lnRef>
+          <a:fillRef idx="3">
+            <a:schemeClr val="accent1"/>
+          </a:fillRef>
+          <a:effectRef idx="2">
+            <a:schemeClr val="accent1"/>
+          </a:effectRef>
+          <a:fontRef idx="minor">
+            <a:schemeClr val="lt1"/>
+          </a:fontRef>
+        </p:style>
+        <p:txBody>
+          <a:bodyPr rtlCol="0" anchor="ctr"/>
+          <a:lstStyle/>
+          <a:p>
+            <a:pPr algn="ctr"/>
+          </a:p>
+        </p:txBody>
+      </p:sp>
+      <p:sp>
+        <p:nvSpPr>
+          <p:cNvPr id="10" name="TextBox 9"/>
+          <p:cNvSpPr txBox="1"/>
+          <p:nvPr/>
+        </p:nvSpPr>
+        <p:spPr>
+          <a:xfrm>
+            <a:off x="685800" y="6583680"/>
+            <a:ext cx="6490411" cy="256032"/>
+          </a:xfrm>
+          <a:prstGeom prst="rect">
+            <a:avLst/>
+          </a:prstGeom>
+          <a:noFill/>
+        </p:spPr>
+        <p:txBody>
+          <a:bodyPr wrap="none">
+            <a:spAutoFit/>
+          </a:bodyPr>
+          <a:lstStyle/>
+          <a:p>
+            <a:pPr algn="l"/>
+            <a:r>
+              <a:rPr sz="700">
+                <a:solidFill>
+                  <a:srgbClr val="A0B4D2"/>
+                </a:solidFill>
+                <a:latin typeface="Consolas"/>
+              </a:rPr>
+              <a:t>FKB Campus  ·  VA01</a:t>
+            </a:r>
+          </a:p>
+        </p:txBody>
+      </p:sp>
+    </p:spTree>
+  </p:cSld>
+  <p:clrMapOvr>
+    <a:masterClrMapping/>
+  </p:clrMapOvr>
+</p:sld>
+</file>
+
+<file path=ppt/slides/slide14.xml><?xml version="1.0" encoding="utf-8"?>
+<p:sld xmlns:a="http://schemas.openxmlformats.org/drawingml/2006/main" xmlns:p="http://schemas.openxmlformats.org/presentationml/2006/main" xmlns:r="http://schemas.openxmlformats.org/officeDocument/2006/relationships">
+  <p:cSld>
+    <p:spTree>
+      <p:nvGrpSpPr>
+        <p:cNvPr id="1" name=""/>
+        <p:cNvGrpSpPr/>
+        <p:nvPr/>
+      </p:nvGrpSpPr>
+      <p:grpSpPr/>
+      <p:sp>
+        <p:nvSpPr>
+          <p:cNvPr id="2" name="Rectangle 1"/>
+          <p:cNvSpPr/>
+          <p:nvPr/>
+        </p:nvSpPr>
+        <p:spPr>
+          <a:xfrm>
+            <a:off x="0" y="0"/>
+            <a:ext cx="12188952" cy="6858000"/>
+          </a:xfrm>
+          <a:prstGeom prst="rect">
+            <a:avLst/>
+          </a:prstGeom>
+          <a:solidFill>
+            <a:srgbClr val="EDEDF3"/>
+          </a:solidFill>
+          <a:ln>
+            <a:noFill/>
+          </a:ln>
+        </p:spPr>
+        <p:style>
+          <a:lnRef idx="1">
+            <a:schemeClr val="accent1"/>
+          </a:lnRef>
+          <a:fillRef idx="3">
+            <a:schemeClr val="accent1"/>
+          </a:fillRef>
+          <a:effectRef idx="2">
+            <a:schemeClr val="accent1"/>
+          </a:effectRef>
+          <a:fontRef idx="minor">
+            <a:schemeClr val="lt1"/>
+          </a:fontRef>
+        </p:style>
+        <p:txBody>
+          <a:bodyPr rtlCol="0" anchor="ctr"/>
+          <a:lstStyle/>
+          <a:p>
+            <a:pPr algn="ctr"/>
+          </a:p>
+        </p:txBody>
+      </p:sp>
+      <p:sp>
+        <p:nvSpPr>
+          <p:cNvPr id="3" name="Rectangle 2"/>
+          <p:cNvSpPr/>
+          <p:nvPr/>
+        </p:nvSpPr>
+        <p:spPr>
+          <a:xfrm>
+            <a:off x="0" y="0"/>
+            <a:ext cx="12188952" cy="50292"/>
+          </a:xfrm>
+          <a:prstGeom prst="rect">
+            <a:avLst/>
+          </a:prstGeom>
+          <a:solidFill>
+            <a:srgbClr val="1F2C56"/>
+          </a:solidFill>
+          <a:ln>
+            <a:noFill/>
+          </a:ln>
+        </p:spPr>
+        <p:style>
+          <a:lnRef idx="1">
+            <a:schemeClr val="accent1"/>
+          </a:lnRef>
+          <a:fillRef idx="3">
+            <a:schemeClr val="accent1"/>
+          </a:fillRef>
+          <a:effectRef idx="2">
+            <a:schemeClr val="accent1"/>
+          </a:effectRef>
+          <a:fontRef idx="minor">
+            <a:schemeClr val="lt1"/>
+          </a:fontRef>
+        </p:style>
+        <p:txBody>
+          <a:bodyPr rtlCol="0" anchor="ctr"/>
+          <a:lstStyle/>
+          <a:p>
+            <a:pPr algn="ctr"/>
+          </a:p>
+        </p:txBody>
+      </p:sp>
+      <p:sp>
+        <p:nvSpPr>
+          <p:cNvPr id="4" name="TextBox 3"/>
+          <p:cNvSpPr txBox="1"/>
+          <p:nvPr/>
+        </p:nvSpPr>
+        <p:spPr>
+          <a:xfrm>
+            <a:off x="685800" y="109728"/>
+            <a:ext cx="10817352" cy="228600"/>
+          </a:xfrm>
+          <a:prstGeom prst="rect">
+            <a:avLst/>
+          </a:prstGeom>
+          <a:noFill/>
+        </p:spPr>
+        <p:txBody>
+          <a:bodyPr wrap="none">
+            <a:spAutoFit/>
+          </a:bodyPr>
+          <a:lstStyle/>
+          <a:p>
+            <a:pPr algn="l"/>
+            <a:r>
+              <a:rPr sz="750">
+                <a:solidFill>
+                  <a:srgbClr val="78808C"/>
+                </a:solidFill>
+                <a:latin typeface="Consolas"/>
+              </a:rPr>
+              <a:t>VA01  ·  ARBEITSBLATT</a:t>
+            </a:r>
+          </a:p>
+        </p:txBody>
+      </p:sp>
+      <p:sp>
+        <p:nvSpPr>
+          <p:cNvPr id="5" name="Rectangle 4"/>
+          <p:cNvSpPr/>
+          <p:nvPr/>
+        </p:nvSpPr>
+        <p:spPr>
+          <a:xfrm>
+            <a:off x="0" y="1234440"/>
+            <a:ext cx="12188952" cy="12700"/>
+          </a:xfrm>
+          <a:prstGeom prst="rect">
+            <a:avLst/>
+          </a:prstGeom>
+          <a:solidFill>
+            <a:srgbClr val="D8DFE4"/>
+          </a:solidFill>
+          <a:ln>
+            <a:noFill/>
+          </a:ln>
+        </p:spPr>
+        <p:style>
+          <a:lnRef idx="1">
+            <a:schemeClr val="accent1"/>
+          </a:lnRef>
+          <a:fillRef idx="3">
+            <a:schemeClr val="accent1"/>
+          </a:fillRef>
+          <a:effectRef idx="2">
+            <a:schemeClr val="accent1"/>
+          </a:effectRef>
+          <a:fontRef idx="minor">
+            <a:schemeClr val="lt1"/>
+          </a:fontRef>
+        </p:style>
+        <p:txBody>
+          <a:bodyPr rtlCol="0" anchor="ctr"/>
+          <a:lstStyle/>
+          <a:p>
+            <a:pPr algn="ctr"/>
+          </a:p>
+        </p:txBody>
+      </p:sp>
+      <p:sp>
+        <p:nvSpPr>
+          <p:cNvPr id="6" name="Rectangle 5"/>
+          <p:cNvSpPr/>
+          <p:nvPr/>
+        </p:nvSpPr>
+        <p:spPr>
+          <a:xfrm>
+            <a:off x="685800" y="502920"/>
+            <a:ext cx="36576" cy="658368"/>
+          </a:xfrm>
+          <a:prstGeom prst="rect">
+            <a:avLst/>
+          </a:prstGeom>
+          <a:solidFill>
+            <a:srgbClr val="D9C089"/>
+          </a:solidFill>
+          <a:ln>
+            <a:noFill/>
+          </a:ln>
+        </p:spPr>
+        <p:style>
+          <a:lnRef idx="1">
+            <a:schemeClr val="accent1"/>
+          </a:lnRef>
+          <a:fillRef idx="3">
+            <a:schemeClr val="accent1"/>
+          </a:fillRef>
+          <a:effectRef idx="2">
+            <a:schemeClr val="accent1"/>
+          </a:effectRef>
+          <a:fontRef idx="minor">
+            <a:schemeClr val="lt1"/>
+          </a:fontRef>
+        </p:style>
+        <p:txBody>
+          <a:bodyPr rtlCol="0" anchor="ctr"/>
+          <a:lstStyle/>
+          <a:p>
+            <a:pPr algn="ctr"/>
+          </a:p>
+        </p:txBody>
+      </p:sp>
+      <p:sp>
+        <p:nvSpPr>
+          <p:cNvPr id="7" name="TextBox 6"/>
+          <p:cNvSpPr txBox="1"/>
+          <p:nvPr/>
+        </p:nvSpPr>
+        <p:spPr>
+          <a:xfrm>
+            <a:off x="813816" y="502920"/>
+            <a:ext cx="10634472" cy="685800"/>
+          </a:xfrm>
+          <a:prstGeom prst="rect">
+            <a:avLst/>
+          </a:prstGeom>
+          <a:noFill/>
+        </p:spPr>
+        <p:txBody>
+          <a:bodyPr wrap="square">
+            <a:spAutoFit/>
+          </a:bodyPr>
+          <a:lstStyle/>
+          <a:p>
+            <a:pPr algn="l"/>
+            <a:r>
+              <a:rPr sz="2400" b="1" i="0">
+                <a:solidFill>
+                  <a:srgbClr val="1F2C56"/>
+                </a:solidFill>
+                <a:latin typeface="Arial"/>
+              </a:rPr>
+              <a:t>Praxisfall bearbeiten: Kreditakte prüfen</a:t>
+            </a:r>
+          </a:p>
+        </p:txBody>
+      </p:sp>
+      <p:sp>
+        <p:nvSpPr>
+          <p:cNvPr id="8" name="TextBox 7"/>
+          <p:cNvSpPr txBox="1"/>
+          <p:nvPr/>
+        </p:nvSpPr>
+        <p:spPr>
+          <a:xfrm>
+            <a:off x="685800" y="1554480"/>
+            <a:ext cx="10817352" cy="3840480"/>
+          </a:xfrm>
+          <a:prstGeom prst="rect">
+            <a:avLst/>
+          </a:prstGeom>
+          <a:noFill/>
+        </p:spPr>
+        <p:txBody>
+          <a:bodyPr wrap="square">
+            <a:spAutoFit/>
+          </a:bodyPr>
+          <a:lstStyle/>
+          <a:p>
+            <a:pPr marL="190500" indent="-190500">
+              <a:spcBef>
+                <a:spcPts val="400"/>
+              </a:spcBef>
+              <a:spcAft>
+                <a:spcPts val="200"/>
+              </a:spcAft>
+            </a:pPr>
+            <a:r>
+              <a:rPr sz="1400">
+                <a:solidFill>
+                  <a:srgbClr val="3D5466"/>
+                </a:solidFill>
+                <a:latin typeface="Arial"/>
+              </a:rPr>
+              <a:t>▸  Ordnen Sie die Unterlagen des Falls den sechs Aktenbereichen zu (AB-1).</a:t>
+            </a:r>
+          </a:p>
+          <a:p>
+            <a:pPr marL="190500" indent="-190500">
+              <a:spcBef>
+                <a:spcPts val="400"/>
+              </a:spcBef>
+              <a:spcAft>
+                <a:spcPts val="200"/>
+              </a:spcAft>
+            </a:pPr>
+            <a:r>
+              <a:rPr sz="1400">
+                <a:solidFill>
+                  <a:srgbClr val="3D5466"/>
+                </a:solidFill>
+                <a:latin typeface="Arial"/>
+              </a:rPr>
+              <a:t>▸  Prüfen Sie die Vollständigkeit mit der Checkliste AB-5 – markieren Sie: vollständig, veraltet oder fehlt.</a:t>
+            </a:r>
+          </a:p>
+          <a:p>
+            <a:pPr marL="190500" indent="-190500">
+              <a:spcBef>
+                <a:spcPts val="400"/>
+              </a:spcBef>
+              <a:spcAft>
+                <a:spcPts val="200"/>
+              </a:spcAft>
+            </a:pPr>
+            <a:r>
+              <a:rPr sz="1400">
+                <a:solidFill>
+                  <a:srgbClr val="3D5466"/>
+                </a:solidFill>
+                <a:latin typeface="Arial"/>
+              </a:rPr>
+              <a:t>▸  Ordnen Sie die § 18 KWG-Unterlagen zu und bewerten Sie ihre Aktualität (AB-3).</a:t>
+            </a:r>
+          </a:p>
+          <a:p>
+            <a:pPr marL="190500" indent="-190500">
+              <a:spcBef>
+                <a:spcPts val="400"/>
+              </a:spcBef>
+              <a:spcAft>
+                <a:spcPts val="200"/>
+              </a:spcAft>
+            </a:pPr>
+            <a:r>
+              <a:rPr sz="1400">
+                <a:solidFill>
+                  <a:srgbClr val="3D5466"/>
+                </a:solidFill>
+                <a:latin typeface="Arial"/>
+              </a:rPr>
+              <a:t>▸  Legen Sie für jede fehlende/veraltete Unterlage einen Nachforderungsvorgang an (AB-4).</a:t>
+            </a:r>
+          </a:p>
+        </p:txBody>
+      </p:sp>
+      <p:sp>
+        <p:nvSpPr>
+          <p:cNvPr id="9" name="Rectangle 8"/>
+          <p:cNvSpPr/>
+          <p:nvPr/>
+        </p:nvSpPr>
+        <p:spPr>
+          <a:xfrm>
+            <a:off x="685800" y="5486400"/>
+            <a:ext cx="10817352" cy="640080"/>
+          </a:xfrm>
+          <a:prstGeom prst="rect">
+            <a:avLst/>
+          </a:prstGeom>
+          <a:solidFill>
+            <a:srgbClr val="1F2C56"/>
+          </a:solidFill>
+          <a:ln>
+            <a:noFill/>
+          </a:ln>
+        </p:spPr>
+        <p:style>
+          <a:lnRef idx="1">
+            <a:schemeClr val="accent1"/>
+          </a:lnRef>
+          <a:fillRef idx="3">
+            <a:schemeClr val="accent1"/>
+          </a:fillRef>
+          <a:effectRef idx="2">
+            <a:schemeClr val="accent1"/>
+          </a:effectRef>
+          <a:fontRef idx="minor">
+            <a:schemeClr val="lt1"/>
+          </a:fontRef>
+        </p:style>
+        <p:txBody>
+          <a:bodyPr rtlCol="0" anchor="ctr"/>
+          <a:lstStyle/>
+          <a:p>
+            <a:pPr algn="ctr"/>
+          </a:p>
+        </p:txBody>
+      </p:sp>
+      <p:sp>
+        <p:nvSpPr>
+          <p:cNvPr id="10" name="TextBox 9"/>
+          <p:cNvSpPr txBox="1"/>
+          <p:nvPr/>
+        </p:nvSpPr>
+        <p:spPr>
+          <a:xfrm>
+            <a:off x="868680" y="5596128"/>
+            <a:ext cx="10451592" cy="457200"/>
+          </a:xfrm>
+          <a:prstGeom prst="rect">
+            <a:avLst/>
+          </a:prstGeom>
+          <a:noFill/>
+        </p:spPr>
+        <p:txBody>
+          <a:bodyPr wrap="square">
+            <a:spAutoFit/>
+          </a:bodyPr>
+          <a:lstStyle/>
+          <a:p>
+            <a:pPr algn="l"/>
+            <a:r>
+              <a:rPr sz="1300" b="1" i="0">
+                <a:solidFill>
+                  <a:srgbClr val="FFFFFF"/>
+                </a:solidFill>
+                <a:latin typeface="Arial"/>
+              </a:rPr>
+              <a:t>→  Bearbeitung im Teilnehmer-Workbook (Arbeitsblatt mit Ausfüllfeldern)</a:t>
+            </a:r>
+          </a:p>
+        </p:txBody>
+      </p:sp>
+      <p:sp>
+        <p:nvSpPr>
+          <p:cNvPr id="11" name="Rectangle 10"/>
+          <p:cNvSpPr/>
+          <p:nvPr/>
+        </p:nvSpPr>
+        <p:spPr>
+          <a:xfrm>
+            <a:off x="0" y="6510528"/>
+            <a:ext cx="12188952" cy="347472"/>
+          </a:xfrm>
+          <a:prstGeom prst="rect">
+            <a:avLst/>
+          </a:prstGeom>
+          <a:solidFill>
+            <a:srgbClr val="0A1937"/>
+          </a:solidFill>
+          <a:ln>
+            <a:noFill/>
+          </a:ln>
+        </p:spPr>
+        <p:style>
+          <a:lnRef idx="1">
+            <a:schemeClr val="accent1"/>
+          </a:lnRef>
+          <a:fillRef idx="3">
+            <a:schemeClr val="accent1"/>
+          </a:fillRef>
+          <a:effectRef idx="2">
+            <a:schemeClr val="accent1"/>
+          </a:effectRef>
+          <a:fontRef idx="minor">
+            <a:schemeClr val="lt1"/>
+          </a:fontRef>
+        </p:style>
+        <p:txBody>
+          <a:bodyPr rtlCol="0" anchor="ctr"/>
+          <a:lstStyle/>
+          <a:p>
+            <a:pPr algn="ctr"/>
+          </a:p>
+        </p:txBody>
+      </p:sp>
+      <p:sp>
+        <p:nvSpPr>
+          <p:cNvPr id="12" name="TextBox 11"/>
+          <p:cNvSpPr txBox="1"/>
+          <p:nvPr/>
+        </p:nvSpPr>
+        <p:spPr>
+          <a:xfrm>
+            <a:off x="685800" y="6583680"/>
+            <a:ext cx="6490411" cy="256032"/>
+          </a:xfrm>
+          <a:prstGeom prst="rect">
+            <a:avLst/>
+          </a:prstGeom>
+          <a:noFill/>
+        </p:spPr>
+        <p:txBody>
+          <a:bodyPr wrap="none">
+            <a:spAutoFit/>
+          </a:bodyPr>
+          <a:lstStyle/>
+          <a:p>
+            <a:pPr algn="l"/>
+            <a:r>
+              <a:rPr sz="700">
+                <a:solidFill>
+                  <a:srgbClr val="A0B4D2"/>
+                </a:solidFill>
+                <a:latin typeface="Consolas"/>
+              </a:rPr>
+              <a:t>FKB Campus  ·  VA01</a:t>
+            </a:r>
+          </a:p>
+        </p:txBody>
+      </p:sp>
+    </p:spTree>
+  </p:cSld>
+  <p:clrMapOvr>
+    <a:masterClrMapping/>
+  </p:clrMapOvr>
+</p:sld>
+</file>
+
+<file path=ppt/slides/slide15.xml><?xml version="1.0" encoding="utf-8"?>
+<p:sld xmlns:a="http://schemas.openxmlformats.org/drawingml/2006/main" xmlns:p="http://schemas.openxmlformats.org/presentationml/2006/main" xmlns:r="http://schemas.openxmlformats.org/officeDocument/2006/relationships">
+  <p:cSld>
+    <p:spTree>
+      <p:nvGrpSpPr>
+        <p:cNvPr id="1" name=""/>
+        <p:cNvGrpSpPr/>
+        <p:nvPr/>
+      </p:nvGrpSpPr>
+      <p:grpSpPr/>
+      <p:sp>
+        <p:nvSpPr>
+          <p:cNvPr id="2" name="Rectangle 1"/>
+          <p:cNvSpPr/>
+          <p:nvPr/>
+        </p:nvSpPr>
+        <p:spPr>
+          <a:xfrm>
+            <a:off x="0" y="0"/>
+            <a:ext cx="12188952" cy="6858000"/>
+          </a:xfrm>
+          <a:prstGeom prst="rect">
+            <a:avLst/>
+          </a:prstGeom>
+          <a:solidFill>
+            <a:srgbClr val="EDEDF3"/>
+          </a:solidFill>
+          <a:ln>
+            <a:noFill/>
+          </a:ln>
+        </p:spPr>
+        <p:style>
+          <a:lnRef idx="1">
+            <a:schemeClr val="accent1"/>
+          </a:lnRef>
+          <a:fillRef idx="3">
+            <a:schemeClr val="accent1"/>
+          </a:fillRef>
+          <a:effectRef idx="2">
+            <a:schemeClr val="accent1"/>
+          </a:effectRef>
+          <a:fontRef idx="minor">
+            <a:schemeClr val="lt1"/>
+          </a:fontRef>
+        </p:style>
+        <p:txBody>
+          <a:bodyPr rtlCol="0" anchor="ctr"/>
+          <a:lstStyle/>
+          <a:p>
+            <a:pPr algn="ctr"/>
+          </a:p>
+        </p:txBody>
+      </p:sp>
+      <p:sp>
+        <p:nvSpPr>
+          <p:cNvPr id="3" name="Rectangle 2"/>
+          <p:cNvSpPr/>
+          <p:nvPr/>
+        </p:nvSpPr>
+        <p:spPr>
+          <a:xfrm>
+            <a:off x="0" y="0"/>
+            <a:ext cx="12188952" cy="50292"/>
+          </a:xfrm>
+          <a:prstGeom prst="rect">
+            <a:avLst/>
+          </a:prstGeom>
+          <a:solidFill>
+            <a:srgbClr val="1F2C56"/>
+          </a:solidFill>
+          <a:ln>
+            <a:noFill/>
+          </a:ln>
+        </p:spPr>
+        <p:style>
+          <a:lnRef idx="1">
+            <a:schemeClr val="accent1"/>
+          </a:lnRef>
+          <a:fillRef idx="3">
+            <a:schemeClr val="accent1"/>
+          </a:fillRef>
+          <a:effectRef idx="2">
+            <a:schemeClr val="accent1"/>
+          </a:effectRef>
+          <a:fontRef idx="minor">
+            <a:schemeClr val="lt1"/>
+          </a:fontRef>
+        </p:style>
+        <p:txBody>
+          <a:bodyPr rtlCol="0" anchor="ctr"/>
+          <a:lstStyle/>
+          <a:p>
+            <a:pPr algn="ctr"/>
+          </a:p>
+        </p:txBody>
+      </p:sp>
+      <p:sp>
+        <p:nvSpPr>
+          <p:cNvPr id="4" name="TextBox 3"/>
+          <p:cNvSpPr txBox="1"/>
+          <p:nvPr/>
+        </p:nvSpPr>
+        <p:spPr>
+          <a:xfrm>
+            <a:off x="685800" y="109728"/>
+            <a:ext cx="10817352" cy="228600"/>
+          </a:xfrm>
+          <a:prstGeom prst="rect">
+            <a:avLst/>
+          </a:prstGeom>
+          <a:noFill/>
+        </p:spPr>
+        <p:txBody>
+          <a:bodyPr wrap="none">
+            <a:spAutoFit/>
+          </a:bodyPr>
+          <a:lstStyle/>
+          <a:p>
+            <a:pPr algn="l"/>
+            <a:r>
+              <a:rPr sz="750">
+                <a:solidFill>
+                  <a:srgbClr val="78808C"/>
+                </a:solidFill>
+                <a:latin typeface="Consolas"/>
+              </a:rPr>
+              <a:t>VA01  ·  INHALT</a:t>
+            </a:r>
+          </a:p>
+        </p:txBody>
+      </p:sp>
+      <p:sp>
+        <p:nvSpPr>
+          <p:cNvPr id="5" name="Rectangle 4"/>
+          <p:cNvSpPr/>
+          <p:nvPr/>
+        </p:nvSpPr>
+        <p:spPr>
+          <a:xfrm>
+            <a:off x="0" y="1234440"/>
+            <a:ext cx="12188952" cy="12700"/>
+          </a:xfrm>
+          <a:prstGeom prst="rect">
+            <a:avLst/>
+          </a:prstGeom>
+          <a:solidFill>
+            <a:srgbClr val="D8DFE4"/>
+          </a:solidFill>
+          <a:ln>
+            <a:noFill/>
+          </a:ln>
+        </p:spPr>
+        <p:style>
+          <a:lnRef idx="1">
+            <a:schemeClr val="accent1"/>
+          </a:lnRef>
+          <a:fillRef idx="3">
+            <a:schemeClr val="accent1"/>
+          </a:fillRef>
+          <a:effectRef idx="2">
+            <a:schemeClr val="accent1"/>
+          </a:effectRef>
+          <a:fontRef idx="minor">
+            <a:schemeClr val="lt1"/>
+          </a:fontRef>
+        </p:style>
+        <p:txBody>
+          <a:bodyPr rtlCol="0" anchor="ctr"/>
+          <a:lstStyle/>
+          <a:p>
+            <a:pPr algn="ctr"/>
+          </a:p>
+        </p:txBody>
+      </p:sp>
+      <p:sp>
+        <p:nvSpPr>
+          <p:cNvPr id="6" name="Rectangle 5"/>
+          <p:cNvSpPr/>
+          <p:nvPr/>
+        </p:nvSpPr>
+        <p:spPr>
+          <a:xfrm>
+            <a:off x="685800" y="502920"/>
+            <a:ext cx="36576" cy="658368"/>
+          </a:xfrm>
+          <a:prstGeom prst="rect">
+            <a:avLst/>
+          </a:prstGeom>
+          <a:solidFill>
+            <a:srgbClr val="D9C089"/>
+          </a:solidFill>
+          <a:ln>
+            <a:noFill/>
+          </a:ln>
+        </p:spPr>
+        <p:style>
+          <a:lnRef idx="1">
+            <a:schemeClr val="accent1"/>
+          </a:lnRef>
+          <a:fillRef idx="3">
+            <a:schemeClr val="accent1"/>
+          </a:fillRef>
+          <a:effectRef idx="2">
+            <a:schemeClr val="accent1"/>
+          </a:effectRef>
+          <a:fontRef idx="minor">
+            <a:schemeClr val="lt1"/>
+          </a:fontRef>
+        </p:style>
+        <p:txBody>
+          <a:bodyPr rtlCol="0" anchor="ctr"/>
+          <a:lstStyle/>
+          <a:p>
+            <a:pPr algn="ctr"/>
+          </a:p>
+        </p:txBody>
+      </p:sp>
+      <p:sp>
+        <p:nvSpPr>
+          <p:cNvPr id="7" name="TextBox 6"/>
+          <p:cNvSpPr txBox="1"/>
+          <p:nvPr/>
+        </p:nvSpPr>
+        <p:spPr>
+          <a:xfrm>
+            <a:off x="813816" y="502920"/>
+            <a:ext cx="10634472" cy="685800"/>
+          </a:xfrm>
+          <a:prstGeom prst="rect">
+            <a:avLst/>
+          </a:prstGeom>
+          <a:noFill/>
+        </p:spPr>
+        <p:txBody>
+          <a:bodyPr wrap="square">
+            <a:spAutoFit/>
+          </a:bodyPr>
+          <a:lstStyle/>
+          <a:p>
+            <a:pPr algn="l"/>
+            <a:r>
+              <a:rPr sz="2400" b="1" i="0">
+                <a:solidFill>
+                  <a:srgbClr val="1F2C56"/>
+                </a:solidFill>
+                <a:latin typeface="Arial"/>
+              </a:rPr>
+              <a:t>Prinzip dieses Moduls</a:t>
+            </a:r>
+          </a:p>
+        </p:txBody>
+      </p:sp>
+      <p:sp>
+        <p:nvSpPr>
+          <p:cNvPr id="8" name="TextBox 7"/>
+          <p:cNvSpPr txBox="1"/>
+          <p:nvPr/>
+        </p:nvSpPr>
+        <p:spPr>
+          <a:xfrm>
+            <a:off x="685800" y="1417320"/>
+            <a:ext cx="10817352" cy="4892040"/>
+          </a:xfrm>
+          <a:prstGeom prst="rect">
+            <a:avLst/>
+          </a:prstGeom>
+          <a:noFill/>
+        </p:spPr>
+        <p:txBody>
+          <a:bodyPr wrap="square" anchor="ctr">
+            <a:spAutoFit/>
+          </a:bodyPr>
+          <a:lstStyle/>
+          <a:p>
+            <a:pPr marL="177800" indent="-177800">
+              <a:spcBef>
+                <a:spcPts val="600"/>
+              </a:spcBef>
+              <a:spcAft>
+                <a:spcPts val="200"/>
+              </a:spcAft>
+            </a:pPr>
+            <a:r>
+              <a:rPr sz="1200" i="1">
+                <a:solidFill>
+                  <a:srgbClr val="3D5466"/>
+                </a:solidFill>
+                <a:latin typeface="Arial"/>
+              </a:rPr>
+              <a:t>→  Eine vollständige Akte ist gelebte Marktfolge.</a:t>
+            </a:r>
+          </a:p>
+          <a:p>
+            <a:pPr marL="190500" indent="-190500">
+              <a:spcBef>
+                <a:spcPts val="400"/>
+              </a:spcBef>
+              <a:spcAft>
+                <a:spcPts val="200"/>
+              </a:spcAft>
+            </a:pPr>
+            <a:r>
+              <a:rPr sz="1300">
+                <a:solidFill>
+                  <a:srgbClr val="3D5466"/>
+                </a:solidFill>
+                <a:latin typeface="Arial"/>
+              </a:rPr>
+              <a:t>▸  Die Sachbearbeitung sichert die aufsichtsrechtliche Funktionstrennung; eine lückenlose Kreditakte schützt Bank und Kunde.</a:t>
+            </a:r>
+          </a:p>
+        </p:txBody>
+      </p:sp>
+      <p:sp>
+        <p:nvSpPr>
+          <p:cNvPr id="9" name="Rectangle 8"/>
+          <p:cNvSpPr/>
+          <p:nvPr/>
+        </p:nvSpPr>
+        <p:spPr>
+          <a:xfrm>
+            <a:off x="0" y="6510528"/>
+            <a:ext cx="12188952" cy="347472"/>
+          </a:xfrm>
+          <a:prstGeom prst="rect">
+            <a:avLst/>
+          </a:prstGeom>
+          <a:solidFill>
+            <a:srgbClr val="0A1937"/>
+          </a:solidFill>
+          <a:ln>
+            <a:noFill/>
+          </a:ln>
+        </p:spPr>
+        <p:style>
+          <a:lnRef idx="1">
+            <a:schemeClr val="accent1"/>
+          </a:lnRef>
+          <a:fillRef idx="3">
+            <a:schemeClr val="accent1"/>
+          </a:fillRef>
+          <a:effectRef idx="2">
+            <a:schemeClr val="accent1"/>
+          </a:effectRef>
+          <a:fontRef idx="minor">
+            <a:schemeClr val="lt1"/>
+          </a:fontRef>
+        </p:style>
+        <p:txBody>
+          <a:bodyPr rtlCol="0" anchor="ctr"/>
+          <a:lstStyle/>
+          <a:p>
+            <a:pPr algn="ctr"/>
+          </a:p>
+        </p:txBody>
+      </p:sp>
+      <p:sp>
+        <p:nvSpPr>
+          <p:cNvPr id="10" name="TextBox 9"/>
+          <p:cNvSpPr txBox="1"/>
+          <p:nvPr/>
+        </p:nvSpPr>
+        <p:spPr>
+          <a:xfrm>
+            <a:off x="685800" y="6583680"/>
+            <a:ext cx="6490411" cy="256032"/>
+          </a:xfrm>
+          <a:prstGeom prst="rect">
+            <a:avLst/>
+          </a:prstGeom>
+          <a:noFill/>
+        </p:spPr>
+        <p:txBody>
+          <a:bodyPr wrap="none">
+            <a:spAutoFit/>
+          </a:bodyPr>
+          <a:lstStyle/>
+          <a:p>
+            <a:pPr algn="l"/>
+            <a:r>
+              <a:rPr sz="700">
+                <a:solidFill>
+                  <a:srgbClr val="A0B4D2"/>
+                </a:solidFill>
+                <a:latin typeface="Consolas"/>
+              </a:rPr>
+              <a:t>FKB Campus  ·  VA01</a:t>
+            </a:r>
+          </a:p>
+        </p:txBody>
+      </p:sp>
+    </p:spTree>
+  </p:cSld>
+  <p:clrMapOvr>
+    <a:masterClrMapping/>
+  </p:clrMapOvr>
+</p:sld>
+</file>
+
+<file path=ppt/slides/slide16.xml><?xml version="1.0" encoding="utf-8"?>
+<p:sld xmlns:a="http://schemas.openxmlformats.org/drawingml/2006/main" xmlns:p="http://schemas.openxmlformats.org/presentationml/2006/main" xmlns:r="http://schemas.openxmlformats.org/officeDocument/2006/relationships">
+  <p:cSld>
+    <p:spTree>
+      <p:nvGrpSpPr>
+        <p:cNvPr id="1" name=""/>
+        <p:cNvGrpSpPr/>
+        <p:nvPr/>
+      </p:nvGrpSpPr>
+      <p:grpSpPr/>
+      <p:sp>
+        <p:nvSpPr>
+          <p:cNvPr id="2" name="Rectangle 1"/>
+          <p:cNvSpPr/>
+          <p:nvPr/>
+        </p:nvSpPr>
+        <p:spPr>
+          <a:xfrm>
+            <a:off x="0" y="0"/>
+            <a:ext cx="12188952" cy="6858000"/>
+          </a:xfrm>
+          <a:prstGeom prst="rect">
+            <a:avLst/>
+          </a:prstGeom>
+          <a:solidFill>
+            <a:srgbClr val="EDEDF3"/>
+          </a:solidFill>
+          <a:ln>
+            <a:noFill/>
+          </a:ln>
+        </p:spPr>
+        <p:style>
+          <a:lnRef idx="1">
+            <a:schemeClr val="accent1"/>
+          </a:lnRef>
+          <a:fillRef idx="3">
+            <a:schemeClr val="accent1"/>
+          </a:fillRef>
+          <a:effectRef idx="2">
+            <a:schemeClr val="accent1"/>
+          </a:effectRef>
+          <a:fontRef idx="minor">
+            <a:schemeClr val="lt1"/>
+          </a:fontRef>
+        </p:style>
+        <p:txBody>
+          <a:bodyPr rtlCol="0" anchor="ctr"/>
+          <a:lstStyle/>
+          <a:p>
+            <a:pPr algn="ctr"/>
+          </a:p>
+        </p:txBody>
+      </p:sp>
+      <p:sp>
+        <p:nvSpPr>
+          <p:cNvPr id="3" name="Rectangle 2"/>
+          <p:cNvSpPr/>
+          <p:nvPr/>
+        </p:nvSpPr>
+        <p:spPr>
+          <a:xfrm>
+            <a:off x="0" y="0"/>
+            <a:ext cx="12188952" cy="50292"/>
+          </a:xfrm>
+          <a:prstGeom prst="rect">
+            <a:avLst/>
+          </a:prstGeom>
+          <a:solidFill>
+            <a:srgbClr val="1F2C56"/>
+          </a:solidFill>
+          <a:ln>
+            <a:noFill/>
+          </a:ln>
+        </p:spPr>
+        <p:style>
+          <a:lnRef idx="1">
+            <a:schemeClr val="accent1"/>
+          </a:lnRef>
+          <a:fillRef idx="3">
+            <a:schemeClr val="accent1"/>
+          </a:fillRef>
+          <a:effectRef idx="2">
+            <a:schemeClr val="accent1"/>
+          </a:effectRef>
+          <a:fontRef idx="minor">
+            <a:schemeClr val="lt1"/>
+          </a:fontRef>
+        </p:style>
+        <p:txBody>
+          <a:bodyPr rtlCol="0" anchor="ctr"/>
+          <a:lstStyle/>
+          <a:p>
+            <a:pPr algn="ctr"/>
+          </a:p>
+        </p:txBody>
+      </p:sp>
+      <p:sp>
+        <p:nvSpPr>
+          <p:cNvPr id="4" name="TextBox 3"/>
+          <p:cNvSpPr txBox="1"/>
+          <p:nvPr/>
+        </p:nvSpPr>
+        <p:spPr>
+          <a:xfrm>
+            <a:off x="685800" y="109728"/>
+            <a:ext cx="10817352" cy="228600"/>
+          </a:xfrm>
+          <a:prstGeom prst="rect">
+            <a:avLst/>
+          </a:prstGeom>
+          <a:noFill/>
+        </p:spPr>
+        <p:txBody>
+          <a:bodyPr wrap="none">
+            <a:spAutoFit/>
+          </a:bodyPr>
+          <a:lstStyle/>
+          <a:p>
+            <a:pPr algn="l"/>
+            <a:r>
+              <a:rPr sz="750">
+                <a:solidFill>
+                  <a:srgbClr val="78808C"/>
+                </a:solidFill>
+                <a:latin typeface="Consolas"/>
+              </a:rPr>
+              <a:t>VA01  ·  INHALT</a:t>
+            </a:r>
+          </a:p>
+        </p:txBody>
+      </p:sp>
+      <p:sp>
+        <p:nvSpPr>
+          <p:cNvPr id="5" name="Rectangle 4"/>
+          <p:cNvSpPr/>
+          <p:nvPr/>
+        </p:nvSpPr>
+        <p:spPr>
+          <a:xfrm>
+            <a:off x="0" y="1234440"/>
+            <a:ext cx="12188952" cy="12700"/>
+          </a:xfrm>
+          <a:prstGeom prst="rect">
+            <a:avLst/>
+          </a:prstGeom>
+          <a:solidFill>
+            <a:srgbClr val="D8DFE4"/>
+          </a:solidFill>
+          <a:ln>
+            <a:noFill/>
+          </a:ln>
+        </p:spPr>
+        <p:style>
+          <a:lnRef idx="1">
+            <a:schemeClr val="accent1"/>
+          </a:lnRef>
+          <a:fillRef idx="3">
+            <a:schemeClr val="accent1"/>
+          </a:fillRef>
+          <a:effectRef idx="2">
+            <a:schemeClr val="accent1"/>
+          </a:effectRef>
+          <a:fontRef idx="minor">
+            <a:schemeClr val="lt1"/>
+          </a:fontRef>
+        </p:style>
+        <p:txBody>
+          <a:bodyPr rtlCol="0" anchor="ctr"/>
+          <a:lstStyle/>
+          <a:p>
+            <a:pPr algn="ctr"/>
+          </a:p>
+        </p:txBody>
+      </p:sp>
+      <p:sp>
+        <p:nvSpPr>
+          <p:cNvPr id="6" name="Rectangle 5"/>
+          <p:cNvSpPr/>
+          <p:nvPr/>
+        </p:nvSpPr>
+        <p:spPr>
+          <a:xfrm>
+            <a:off x="685800" y="502920"/>
+            <a:ext cx="36576" cy="658368"/>
+          </a:xfrm>
+          <a:prstGeom prst="rect">
+            <a:avLst/>
+          </a:prstGeom>
+          <a:solidFill>
+            <a:srgbClr val="D9C089"/>
+          </a:solidFill>
+          <a:ln>
+            <a:noFill/>
+          </a:ln>
+        </p:spPr>
+        <p:style>
+          <a:lnRef idx="1">
+            <a:schemeClr val="accent1"/>
+          </a:lnRef>
+          <a:fillRef idx="3">
+            <a:schemeClr val="accent1"/>
+          </a:fillRef>
+          <a:effectRef idx="2">
+            <a:schemeClr val="accent1"/>
+          </a:effectRef>
+          <a:fontRef idx="minor">
+            <a:schemeClr val="lt1"/>
+          </a:fontRef>
+        </p:style>
+        <p:txBody>
+          <a:bodyPr rtlCol="0" anchor="ctr"/>
+          <a:lstStyle/>
+          <a:p>
+            <a:pPr algn="ctr"/>
+          </a:p>
+        </p:txBody>
+      </p:sp>
+      <p:sp>
+        <p:nvSpPr>
+          <p:cNvPr id="7" name="TextBox 6"/>
+          <p:cNvSpPr txBox="1"/>
+          <p:nvPr/>
+        </p:nvSpPr>
+        <p:spPr>
+          <a:xfrm>
+            <a:off x="813816" y="502920"/>
+            <a:ext cx="10634472" cy="685800"/>
+          </a:xfrm>
+          <a:prstGeom prst="rect">
+            <a:avLst/>
+          </a:prstGeom>
+          <a:noFill/>
+        </p:spPr>
+        <p:txBody>
+          <a:bodyPr wrap="square">
+            <a:spAutoFit/>
+          </a:bodyPr>
+          <a:lstStyle/>
+          <a:p>
+            <a:pPr algn="l"/>
+            <a:r>
+              <a:rPr sz="2400" b="1" i="0">
+                <a:solidFill>
+                  <a:srgbClr val="1F2C56"/>
+                </a:solidFill>
+                <a:latin typeface="Arial"/>
+              </a:rPr>
+              <a:t>Reflexionsfragen</a:t>
+            </a:r>
+          </a:p>
+        </p:txBody>
+      </p:sp>
+      <p:sp>
+        <p:nvSpPr>
+          <p:cNvPr id="8" name="TextBox 7"/>
+          <p:cNvSpPr txBox="1"/>
+          <p:nvPr/>
+        </p:nvSpPr>
+        <p:spPr>
+          <a:xfrm>
+            <a:off x="685800" y="1417320"/>
+            <a:ext cx="10817352" cy="4892040"/>
+          </a:xfrm>
+          <a:prstGeom prst="rect">
+            <a:avLst/>
+          </a:prstGeom>
+          <a:noFill/>
+        </p:spPr>
+        <p:txBody>
+          <a:bodyPr wrap="square" anchor="ctr">
+            <a:spAutoFit/>
+          </a:bodyPr>
+          <a:lstStyle/>
+          <a:p>
+            <a:pPr marL="190500" indent="-190500">
+              <a:spcBef>
+                <a:spcPts val="400"/>
+              </a:spcBef>
+              <a:spcAft>
+                <a:spcPts val="200"/>
+              </a:spcAft>
+            </a:pPr>
+            <a:r>
+              <a:rPr sz="1300">
+                <a:solidFill>
+                  <a:srgbClr val="3D5466"/>
+                </a:solidFill>
+                <a:latin typeface="Arial"/>
+              </a:rPr>
+              <a:t>▸  Welche Unterlage fehlt in Ihrer Praxis am häufigsten – und woran liegt das?</a:t>
+            </a:r>
+          </a:p>
+          <a:p>
+            <a:pPr marL="190500" indent="-190500">
+              <a:spcBef>
+                <a:spcPts val="400"/>
+              </a:spcBef>
+              <a:spcAft>
+                <a:spcPts val="200"/>
+              </a:spcAft>
+            </a:pPr>
+            <a:r>
+              <a:rPr sz="1300">
+                <a:solidFill>
+                  <a:srgbClr val="3D5466"/>
+                </a:solidFill>
+                <a:latin typeface="Arial"/>
+              </a:rPr>
+              <a:t>▸  Wie erklären Sie einem Berater freundlich, dass eine Akte vor der Auszahlung noch nicht vollständig ist?</a:t>
+            </a:r>
+          </a:p>
+          <a:p>
+            <a:pPr marL="190500" indent="-190500">
+              <a:spcBef>
+                <a:spcPts val="400"/>
+              </a:spcBef>
+              <a:spcAft>
+                <a:spcPts val="200"/>
+              </a:spcAft>
+            </a:pPr>
+            <a:r>
+              <a:rPr sz="1300">
+                <a:solidFill>
+                  <a:srgbClr val="3D5466"/>
+                </a:solidFill>
+                <a:latin typeface="Arial"/>
+              </a:rPr>
+              <a:t>▸  Woran erkennen Sie, dass eine Offenlegungsunterlage nicht mehr aktuell genug ist?</a:t>
+            </a:r>
+          </a:p>
+          <a:p>
+            <a:pPr marL="190500" indent="-190500">
+              <a:spcBef>
+                <a:spcPts val="400"/>
+              </a:spcBef>
+              <a:spcAft>
+                <a:spcPts val="200"/>
+              </a:spcAft>
+            </a:pPr>
+            <a:r>
+              <a:rPr sz="1300">
+                <a:solidFill>
+                  <a:srgbClr val="3D5466"/>
+                </a:solidFill>
+                <a:latin typeface="Arial"/>
+              </a:rPr>
+              <a:t>▸  Wie reagieren Sie, wenn ein Firmenkunde direkt nach dem Stand seiner Auszahlung fragt – aber noch Unterlagen fehlen und der Berater im Termin ist?</a:t>
+            </a:r>
+          </a:p>
+        </p:txBody>
+      </p:sp>
+      <p:sp>
+        <p:nvSpPr>
+          <p:cNvPr id="9" name="Rectangle 8"/>
+          <p:cNvSpPr/>
+          <p:nvPr/>
+        </p:nvSpPr>
+        <p:spPr>
+          <a:xfrm>
+            <a:off x="0" y="6510528"/>
+            <a:ext cx="12188952" cy="347472"/>
+          </a:xfrm>
+          <a:prstGeom prst="rect">
+            <a:avLst/>
+          </a:prstGeom>
+          <a:solidFill>
+            <a:srgbClr val="0A1937"/>
+          </a:solidFill>
+          <a:ln>
+            <a:noFill/>
+          </a:ln>
+        </p:spPr>
+        <p:style>
+          <a:lnRef idx="1">
+            <a:schemeClr val="accent1"/>
+          </a:lnRef>
+          <a:fillRef idx="3">
+            <a:schemeClr val="accent1"/>
+          </a:fillRef>
+          <a:effectRef idx="2">
+            <a:schemeClr val="accent1"/>
+          </a:effectRef>
+          <a:fontRef idx="minor">
+            <a:schemeClr val="lt1"/>
+          </a:fontRef>
+        </p:style>
+        <p:txBody>
+          <a:bodyPr rtlCol="0" anchor="ctr"/>
+          <a:lstStyle/>
+          <a:p>
+            <a:pPr algn="ctr"/>
+          </a:p>
+        </p:txBody>
+      </p:sp>
+      <p:sp>
+        <p:nvSpPr>
+          <p:cNvPr id="10" name="TextBox 9"/>
+          <p:cNvSpPr txBox="1"/>
+          <p:nvPr/>
+        </p:nvSpPr>
+        <p:spPr>
+          <a:xfrm>
+            <a:off x="685800" y="6583680"/>
+            <a:ext cx="6490411" cy="256032"/>
+          </a:xfrm>
+          <a:prstGeom prst="rect">
+            <a:avLst/>
+          </a:prstGeom>
+          <a:noFill/>
+        </p:spPr>
+        <p:txBody>
+          <a:bodyPr wrap="none">
+            <a:spAutoFit/>
+          </a:bodyPr>
+          <a:lstStyle/>
+          <a:p>
+            <a:pPr algn="l"/>
+            <a:r>
+              <a:rPr sz="700">
+                <a:solidFill>
+                  <a:srgbClr val="A0B4D2"/>
+                </a:solidFill>
+                <a:latin typeface="Consolas"/>
+              </a:rPr>
+              <a:t>FKB Campus  ·  VA01</a:t>
+            </a:r>
+          </a:p>
+        </p:txBody>
+      </p:sp>
+    </p:spTree>
+  </p:cSld>
+  <p:clrMapOvr>
+    <a:masterClrMapping/>
+  </p:clrMapOvr>
+</p:sld>
+</file>
+
 <file path=ppt/slides/slide2.xml><?xml version="1.0" encoding="utf-8"?>
 <p:sld xmlns:a="http://schemas.openxmlformats.org/drawingml/2006/main" xmlns:p="http://schemas.openxmlformats.org/presentationml/2006/main" xmlns:r="http://schemas.openxmlformats.org/officeDocument/2006/relationships">
   <p:cSld>
@@ -5840,7 +8946,7 @@
             <a:avLst/>
           </a:prstGeom>
           <a:solidFill>
-            <a:srgbClr val="EDEDF3"/>
+            <a:srgbClr val="1F2C56"/>
           </a:solidFill>
           <a:ln>
             <a:noFill/>
@@ -5870,57 +8976,14 @@
       </p:sp>
       <p:sp>
         <p:nvSpPr>
-          <p:cNvPr id="3" name="Rectangle 2"/>
-          <p:cNvSpPr/>
-          <p:nvPr/>
-        </p:nvSpPr>
-        <p:spPr>
-          <a:xfrm>
-            <a:off x="0" y="0"/>
-            <a:ext cx="12188952" cy="50292"/>
-          </a:xfrm>
-          <a:prstGeom prst="rect">
-            <a:avLst/>
-          </a:prstGeom>
-          <a:solidFill>
-            <a:srgbClr val="1F2C56"/>
-          </a:solidFill>
-          <a:ln>
-            <a:noFill/>
-          </a:ln>
-        </p:spPr>
-        <p:style>
-          <a:lnRef idx="1">
-            <a:schemeClr val="accent1"/>
-          </a:lnRef>
-          <a:fillRef idx="3">
-            <a:schemeClr val="accent1"/>
-          </a:fillRef>
-          <a:effectRef idx="2">
-            <a:schemeClr val="accent1"/>
-          </a:effectRef>
-          <a:fontRef idx="minor">
-            <a:schemeClr val="lt1"/>
-          </a:fontRef>
-        </p:style>
-        <p:txBody>
-          <a:bodyPr rtlCol="0" anchor="ctr"/>
-          <a:lstStyle/>
-          <a:p>
-            <a:pPr algn="ctr"/>
-          </a:p>
-        </p:txBody>
-      </p:sp>
-      <p:sp>
-        <p:nvSpPr>
-          <p:cNvPr id="4" name="TextBox 3"/>
+          <p:cNvPr id="3" name="TextBox 2"/>
           <p:cNvSpPr txBox="1"/>
           <p:nvPr/>
         </p:nvSpPr>
         <p:spPr>
           <a:xfrm>
-            <a:off x="685800" y="109728"/>
-            <a:ext cx="10817352" cy="228600"/>
+            <a:off x="685800" y="2377440"/>
+            <a:ext cx="10817352" cy="365760"/>
           </a:xfrm>
           <a:prstGeom prst="rect">
             <a:avLst/>
@@ -5935,70 +8998,27 @@
           <a:p>
             <a:pPr algn="l"/>
             <a:r>
-              <a:rPr sz="750">
-                <a:solidFill>
-                  <a:srgbClr val="78808C"/>
+              <a:rPr sz="1200">
+                <a:solidFill>
+                  <a:srgbClr val="D9C089"/>
                 </a:solidFill>
                 <a:latin typeface="Consolas"/>
               </a:rPr>
-              <a:t>VA01  ·  INHALT</a:t>
-            </a:r>
-          </a:p>
-        </p:txBody>
-      </p:sp>
-      <p:sp>
-        <p:nvSpPr>
-          <p:cNvPr id="5" name="Rectangle 4"/>
+              <a:t>00:05–00:20</a:t>
+            </a:r>
+          </a:p>
+        </p:txBody>
+      </p:sp>
+      <p:sp>
+        <p:nvSpPr>
+          <p:cNvPr id="4" name="Rectangle 3"/>
           <p:cNvSpPr/>
           <p:nvPr/>
         </p:nvSpPr>
         <p:spPr>
           <a:xfrm>
-            <a:off x="0" y="1234440"/>
-            <a:ext cx="12188952" cy="12700"/>
-          </a:xfrm>
-          <a:prstGeom prst="rect">
-            <a:avLst/>
-          </a:prstGeom>
-          <a:solidFill>
-            <a:srgbClr val="D8DFE4"/>
-          </a:solidFill>
-          <a:ln>
-            <a:noFill/>
-          </a:ln>
-        </p:spPr>
-        <p:style>
-          <a:lnRef idx="1">
-            <a:schemeClr val="accent1"/>
-          </a:lnRef>
-          <a:fillRef idx="3">
-            <a:schemeClr val="accent1"/>
-          </a:fillRef>
-          <a:effectRef idx="2">
-            <a:schemeClr val="accent1"/>
-          </a:effectRef>
-          <a:fontRef idx="minor">
-            <a:schemeClr val="lt1"/>
-          </a:fontRef>
-        </p:style>
-        <p:txBody>
-          <a:bodyPr rtlCol="0" anchor="ctr"/>
-          <a:lstStyle/>
-          <a:p>
-            <a:pPr algn="ctr"/>
-          </a:p>
-        </p:txBody>
-      </p:sp>
-      <p:sp>
-        <p:nvSpPr>
-          <p:cNvPr id="6" name="Rectangle 5"/>
-          <p:cNvSpPr/>
-          <p:nvPr/>
-        </p:nvSpPr>
-        <p:spPr>
-          <a:xfrm>
-            <a:off x="685800" y="502920"/>
-            <a:ext cx="36576" cy="658368"/>
+            <a:off x="685800" y="2788920"/>
+            <a:ext cx="548640" cy="38100"/>
           </a:xfrm>
           <a:prstGeom prst="rect">
             <a:avLst/>
@@ -6034,14 +9054,14 @@
       </p:sp>
       <p:sp>
         <p:nvSpPr>
-          <p:cNvPr id="7" name="TextBox 6"/>
+          <p:cNvPr id="5" name="TextBox 4"/>
           <p:cNvSpPr txBox="1"/>
           <p:nvPr/>
         </p:nvSpPr>
         <p:spPr>
           <a:xfrm>
-            <a:off x="813816" y="502920"/>
-            <a:ext cx="10634472" cy="685800"/>
+            <a:off x="685800" y="3017520"/>
+            <a:ext cx="10817352" cy="1463040"/>
           </a:xfrm>
           <a:prstGeom prst="rect">
             <a:avLst/>
@@ -6056,27 +9076,27 @@
           <a:p>
             <a:pPr algn="l"/>
             <a:r>
-              <a:rPr sz="2400" b="1" i="0">
-                <a:solidFill>
-                  <a:srgbClr val="1F2C56"/>
+              <a:rPr sz="4000" b="1" i="0">
+                <a:solidFill>
+                  <a:srgbClr val="FFFFFF"/>
                 </a:solidFill>
                 <a:latin typeface="Arial"/>
               </a:rPr>
-              <a:t>Theorie-Input: Die Kreditakte – Zweck, Aufbau, Pflichtbestandteile</a:t>
-            </a:r>
-          </a:p>
-        </p:txBody>
-      </p:sp>
-      <p:sp>
-        <p:nvSpPr>
-          <p:cNvPr id="8" name="TextBox 7"/>
+              <a:t>Theorie-Input 1</a:t>
+            </a:r>
+          </a:p>
+        </p:txBody>
+      </p:sp>
+      <p:sp>
+        <p:nvSpPr>
+          <p:cNvPr id="6" name="TextBox 5"/>
           <p:cNvSpPr txBox="1"/>
           <p:nvPr/>
         </p:nvSpPr>
         <p:spPr>
           <a:xfrm>
-            <a:off x="685800" y="1417320"/>
-            <a:ext cx="10817352" cy="4892040"/>
+            <a:off x="685800" y="4480560"/>
+            <a:ext cx="8653881" cy="1280160"/>
           </a:xfrm>
           <a:prstGeom prst="rect">
             <a:avLst/>
@@ -6084,103 +9104,34 @@
           <a:noFill/>
         </p:spPr>
         <p:txBody>
-          <a:bodyPr wrap="square" anchor="ctr">
+          <a:bodyPr wrap="square">
             <a:spAutoFit/>
           </a:bodyPr>
           <a:lstStyle/>
           <a:p>
-            <a:pPr marL="190500" indent="-190500">
-              <a:spcBef>
-                <a:spcPts val="400"/>
-              </a:spcBef>
-              <a:spcAft>
-                <a:spcPts val="200"/>
-              </a:spcAft>
-            </a:pPr>
-            <a:r>
-              <a:rPr sz="1300">
-                <a:solidFill>
-                  <a:srgbClr val="3D5466"/>
+            <a:pPr algn="l"/>
+            <a:r>
+              <a:rPr sz="1600" b="0" i="0">
+                <a:solidFill>
+                  <a:srgbClr val="C8D2E6"/>
                 </a:solidFill>
                 <a:latin typeface="Arial"/>
               </a:rPr>
-              <a:t>▸  Typische Bestandteile einer Firmenkunden-Kreditakte:</a:t>
-            </a:r>
-          </a:p>
-          <a:p>
-            <a:pPr marL="177800" indent="-177800">
-              <a:spcBef>
-                <a:spcPts val="600"/>
-              </a:spcBef>
-              <a:spcAft>
-                <a:spcPts val="200"/>
-              </a:spcAft>
-            </a:pPr>
-            <a:r>
-              <a:rPr sz="1200" i="1">
-                <a:solidFill>
-                  <a:srgbClr val="3D5466"/>
-                </a:solidFill>
-                <a:latin typeface="Arial"/>
-              </a:rPr>
-              <a:t>→  Praxishinweis – Digitale oder physische Akte?</a:t>
-            </a:r>
-          </a:p>
-        </p:txBody>
-      </p:sp>
-      <p:sp>
-        <p:nvSpPr>
-          <p:cNvPr id="9" name="Rectangle 8"/>
-          <p:cNvSpPr/>
-          <p:nvPr/>
-        </p:nvSpPr>
-        <p:spPr>
-          <a:xfrm>
-            <a:off x="0" y="6510528"/>
-            <a:ext cx="12188952" cy="347472"/>
-          </a:xfrm>
-          <a:prstGeom prst="rect">
-            <a:avLst/>
-          </a:prstGeom>
-          <a:solidFill>
-            <a:srgbClr val="0A1937"/>
-          </a:solidFill>
-          <a:ln>
-            <a:noFill/>
-          </a:ln>
-        </p:spPr>
-        <p:style>
-          <a:lnRef idx="1">
-            <a:schemeClr val="accent1"/>
-          </a:lnRef>
-          <a:fillRef idx="3">
-            <a:schemeClr val="accent1"/>
-          </a:fillRef>
-          <a:effectRef idx="2">
-            <a:schemeClr val="accent1"/>
-          </a:effectRef>
-          <a:fontRef idx="minor">
-            <a:schemeClr val="lt1"/>
-          </a:fontRef>
-        </p:style>
-        <p:txBody>
-          <a:bodyPr rtlCol="0" anchor="ctr"/>
-          <a:lstStyle/>
-          <a:p>
-            <a:pPr algn="ctr"/>
-          </a:p>
-        </p:txBody>
-      </p:sp>
-      <p:sp>
-        <p:nvSpPr>
-          <p:cNvPr id="10" name="TextBox 9"/>
+              <a:t>Aufbau, Zweck und die sechs Bereiche einer Kreditakte verstehen.</a:t>
+            </a:r>
+          </a:p>
+        </p:txBody>
+      </p:sp>
+      <p:sp>
+        <p:nvSpPr>
+          <p:cNvPr id="7" name="TextBox 6"/>
           <p:cNvSpPr txBox="1"/>
           <p:nvPr/>
         </p:nvSpPr>
         <p:spPr>
           <a:xfrm>
-            <a:off x="685800" y="6583680"/>
-            <a:ext cx="6490411" cy="256032"/>
+            <a:off x="685800" y="6355080"/>
+            <a:ext cx="10817352" cy="274320"/>
           </a:xfrm>
           <a:prstGeom prst="rect">
             <a:avLst/>
@@ -6197,7 +9148,7 @@
             <a:r>
               <a:rPr sz="700">
                 <a:solidFill>
-                  <a:srgbClr val="A0B4D2"/>
+                  <a:srgbClr val="8CA0C3"/>
                 </a:solidFill>
                 <a:latin typeface="Consolas"/>
               </a:rPr>
@@ -6461,7 +9412,7 @@
                 </a:solidFill>
                 <a:latin typeface="Arial"/>
               </a:rPr>
-              <a:t>Theorie-Input: Funktionstrennung und § 18 KWG</a:t>
+              <a:t>Die Kreditakte: Zweck und Aufbau</a:t>
             </a:r>
           </a:p>
         </p:txBody>
@@ -6503,7 +9454,64 @@
                 </a:solidFill>
                 <a:latin typeface="Arial"/>
               </a:rPr>
-              <a:t>→  Praxishinweis – Interne Offenlegungsgrenze beachten</a:t>
+              <a:t>→  Die Kreditakte ist das Gedächtnis des Engagements – sie belegt lückenlos, dass die Bank sorgfältig entschieden hat und laufend überwacht.</a:t>
+            </a:r>
+          </a:p>
+          <a:p>
+            <a:pPr marL="190500" indent="-190500">
+              <a:spcBef>
+                <a:spcPts val="400"/>
+              </a:spcBef>
+              <a:spcAft>
+                <a:spcPts val="200"/>
+              </a:spcAft>
+            </a:pPr>
+            <a:r>
+              <a:rPr sz="1300">
+                <a:solidFill>
+                  <a:srgbClr val="3D5466"/>
+                </a:solidFill>
+                <a:latin typeface="Arial"/>
+              </a:rPr>
+              <a:t>▸  Sie dokumentiert die gesamte Geschäftsbeziehung von der Antragstellung bis zur Rückzahlung.</a:t>
+            </a:r>
+          </a:p>
+          <a:p>
+            <a:pPr marL="190500" indent="-190500">
+              <a:spcBef>
+                <a:spcPts val="400"/>
+              </a:spcBef>
+              <a:spcAft>
+                <a:spcPts val="200"/>
+              </a:spcAft>
+            </a:pPr>
+            <a:r>
+              <a:rPr sz="1300">
+                <a:solidFill>
+                  <a:srgbClr val="3D5466"/>
+                </a:solidFill>
+                <a:latin typeface="Arial"/>
+              </a:rPr>
+              <a:t>▸  Sie ist Grundlage jeder Prüfung durch Interne Revision, Wirtschaftsprüfer und Bankenaufsicht.</a:t>
+            </a:r>
+          </a:p>
+          <a:p>
+            <a:pPr marL="190500" indent="-190500">
+              <a:spcBef>
+                <a:spcPts val="400"/>
+              </a:spcBef>
+              <a:spcAft>
+                <a:spcPts val="200"/>
+              </a:spcAft>
+            </a:pPr>
+            <a:r>
+              <a:rPr sz="1300">
+                <a:solidFill>
+                  <a:srgbClr val="3D5466"/>
+                </a:solidFill>
+                <a:latin typeface="Arial"/>
+              </a:rPr>
+              <a:t>▸  Ordnungsmäßigkeit heißt zweierlei – alle Pflichtunterlagen vorhanden und aktuell genug.</a:t>
             </a:r>
           </a:p>
         </p:txBody>
@@ -6619,7 +9627,7 @@
             <a:avLst/>
           </a:prstGeom>
           <a:solidFill>
-            <a:srgbClr val="EDEDF3"/>
+            <a:srgbClr val="FFFFFF"/>
           </a:solidFill>
           <a:ln>
             <a:noFill/>
@@ -6720,51 +9728,43 @@
                 </a:solidFill>
                 <a:latin typeface="Consolas"/>
               </a:rPr>
-              <a:t>VA01  ·  ARBEITSBLATT</a:t>
-            </a:r>
-          </a:p>
-        </p:txBody>
-      </p:sp>
-      <p:sp>
-        <p:nvSpPr>
-          <p:cNvPr id="5" name="Rectangle 4"/>
-          <p:cNvSpPr/>
-          <p:nvPr/>
-        </p:nvSpPr>
-        <p:spPr>
-          <a:xfrm>
-            <a:off x="0" y="1234440"/>
-            <a:ext cx="12188952" cy="12700"/>
-          </a:xfrm>
-          <a:prstGeom prst="rect">
-            <a:avLst/>
-          </a:prstGeom>
-          <a:solidFill>
-            <a:srgbClr val="D8DFE4"/>
-          </a:solidFill>
-          <a:ln>
-            <a:noFill/>
-          </a:ln>
-        </p:spPr>
-        <p:style>
-          <a:lnRef idx="1">
-            <a:schemeClr val="accent1"/>
-          </a:lnRef>
-          <a:fillRef idx="3">
-            <a:schemeClr val="accent1"/>
-          </a:fillRef>
-          <a:effectRef idx="2">
-            <a:schemeClr val="accent1"/>
-          </a:effectRef>
-          <a:fontRef idx="minor">
-            <a:schemeClr val="lt1"/>
-          </a:fontRef>
-        </p:style>
-        <p:txBody>
-          <a:bodyPr rtlCol="0" anchor="ctr"/>
-          <a:lstStyle/>
-          <a:p>
-            <a:pPr algn="ctr"/>
+              <a:t>VA01  ·  SCHAUBILD</a:t>
+            </a:r>
+          </a:p>
+        </p:txBody>
+      </p:sp>
+      <p:sp>
+        <p:nvSpPr>
+          <p:cNvPr id="5" name="TextBox 4"/>
+          <p:cNvSpPr txBox="1"/>
+          <p:nvPr/>
+        </p:nvSpPr>
+        <p:spPr>
+          <a:xfrm>
+            <a:off x="685800" y="502920"/>
+            <a:ext cx="10817352" cy="594360"/>
+          </a:xfrm>
+          <a:prstGeom prst="rect">
+            <a:avLst/>
+          </a:prstGeom>
+          <a:noFill/>
+        </p:spPr>
+        <p:txBody>
+          <a:bodyPr wrap="square">
+            <a:spAutoFit/>
+          </a:bodyPr>
+          <a:lstStyle/>
+          <a:p>
+            <a:pPr algn="l"/>
+            <a:r>
+              <a:rPr sz="2000" b="1" i="0">
+                <a:solidFill>
+                  <a:srgbClr val="1F2C56"/>
+                </a:solidFill>
+                <a:latin typeface="Arial"/>
+              </a:rPr>
+              <a:t>Die sechs Bereiche einer Firmenkunden-Kreditakte</a:t>
+            </a:r>
           </a:p>
         </p:txBody>
       </p:sp>
@@ -6776,8 +9776,8 @@
         </p:nvSpPr>
         <p:spPr>
           <a:xfrm>
-            <a:off x="685800" y="502920"/>
-            <a:ext cx="36576" cy="658368"/>
+            <a:off x="685800" y="1143000"/>
+            <a:ext cx="10817352" cy="25400"/>
           </a:xfrm>
           <a:prstGeom prst="rect">
             <a:avLst/>
@@ -6811,240 +9811,33 @@
           </a:p>
         </p:txBody>
       </p:sp>
-      <p:sp>
-        <p:nvSpPr>
-          <p:cNvPr id="7" name="TextBox 6"/>
-          <p:cNvSpPr txBox="1"/>
-          <p:nvPr/>
-        </p:nvSpPr>
-        <p:spPr>
-          <a:xfrm>
-            <a:off x="813816" y="502920"/>
-            <a:ext cx="10634472" cy="685800"/>
-          </a:xfrm>
-          <a:prstGeom prst="rect">
-            <a:avLst/>
-          </a:prstGeom>
-          <a:noFill/>
-        </p:spPr>
-        <p:txBody>
-          <a:bodyPr wrap="square">
-            <a:spAutoFit/>
-          </a:bodyPr>
-          <a:lstStyle/>
-          <a:p>
-            <a:pPr algn="l"/>
-            <a:r>
-              <a:rPr sz="2400" b="1" i="0">
-                <a:solidFill>
-                  <a:srgbClr val="1F2C56"/>
-                </a:solidFill>
-                <a:latin typeface="Arial"/>
-              </a:rPr>
-              <a:t>Praxisfall: Holzbau Musterregion GmbH</a:t>
-            </a:r>
-          </a:p>
-        </p:txBody>
-      </p:sp>
-      <p:sp>
-        <p:nvSpPr>
-          <p:cNvPr id="8" name="TextBox 7"/>
-          <p:cNvSpPr txBox="1"/>
-          <p:nvPr/>
-        </p:nvSpPr>
-        <p:spPr>
-          <a:xfrm>
-            <a:off x="685800" y="1554480"/>
-            <a:ext cx="10817352" cy="3840480"/>
-          </a:xfrm>
-          <a:prstGeom prst="rect">
-            <a:avLst/>
-          </a:prstGeom>
-          <a:noFill/>
-        </p:spPr>
-        <p:txBody>
-          <a:bodyPr wrap="square">
-            <a:spAutoFit/>
-          </a:bodyPr>
-          <a:lstStyle/>
-          <a:p>
-            <a:pPr marL="190500" indent="-190500">
-              <a:spcBef>
-                <a:spcPts val="400"/>
-              </a:spcBef>
-              <a:spcAft>
-                <a:spcPts val="200"/>
-              </a:spcAft>
-            </a:pPr>
-            <a:r>
-              <a:rPr sz="1400">
-                <a:solidFill>
-                  <a:srgbClr val="3D5466"/>
-                </a:solidFill>
-                <a:latin typeface="Arial"/>
-              </a:rPr>
-              <a:t>▸  Unternehmensportrait (anonymisiert, branchentypisch)</a:t>
-            </a:r>
-          </a:p>
-          <a:p>
-            <a:pPr marL="190500" indent="-190500">
-              <a:spcBef>
-                <a:spcPts val="400"/>
-              </a:spcBef>
-              <a:spcAft>
-                <a:spcPts val="200"/>
-              </a:spcAft>
-            </a:pPr>
-            <a:r>
-              <a:rPr sz="1400">
-                <a:solidFill>
-                  <a:srgbClr val="3D5466"/>
-                </a:solidFill>
-                <a:latin typeface="Arial"/>
-              </a:rPr>
-              <a:t>▸  Akteninhalt (Ist-Stand):</a:t>
-            </a:r>
-          </a:p>
-          <a:p>
-            <a:pPr marL="190500" indent="-190500">
-              <a:spcBef>
-                <a:spcPts val="400"/>
-              </a:spcBef>
-              <a:spcAft>
-                <a:spcPts val="200"/>
-              </a:spcAft>
-            </a:pPr>
-            <a:r>
-              <a:rPr sz="1400">
-                <a:solidFill>
-                  <a:srgbClr val="3D5466"/>
-                </a:solidFill>
-                <a:latin typeface="Arial"/>
-              </a:rPr>
-              <a:t>▸  Die folgende Handlungsempfehlung verknüpft typische Aktenmängel mit der passenden Reaktion – nutzen Sie sie bei der Fallarbeit.</a:t>
-            </a:r>
-          </a:p>
-          <a:p>
-            <a:pPr marL="190500" indent="-190500">
-              <a:spcBef>
-                <a:spcPts val="400"/>
-              </a:spcBef>
-              <a:spcAft>
-                <a:spcPts val="200"/>
-              </a:spcAft>
-            </a:pPr>
-            <a:r>
-              <a:rPr sz="1400">
-                <a:solidFill>
-                  <a:srgbClr val="3D5466"/>
-                </a:solidFill>
-                <a:latin typeface="Arial"/>
-              </a:rPr>
-              <a:t>▸  Pflichtbestandteile zuordnen</a:t>
-            </a:r>
-          </a:p>
-          <a:p>
-            <a:pPr marL="190500" indent="-190500">
-              <a:spcBef>
-                <a:spcPts val="400"/>
-              </a:spcBef>
-              <a:spcAft>
-                <a:spcPts val="200"/>
-              </a:spcAft>
-            </a:pPr>
-            <a:r>
-              <a:rPr sz="1400">
-                <a:solidFill>
-                  <a:srgbClr val="3D5466"/>
-                </a:solidFill>
-                <a:latin typeface="Arial"/>
-              </a:rPr>
-              <a:t>▸  Anleitung: Ordnen Sie die Unterlagen des Falls den sechs Aktenbereichen zu. Tragen Sie je Bereich mindestens eine Unterlage ein.</a:t>
-            </a:r>
-          </a:p>
-        </p:txBody>
-      </p:sp>
-      <p:sp>
-        <p:nvSpPr>
-          <p:cNvPr id="9" name="Rectangle 8"/>
-          <p:cNvSpPr/>
-          <p:nvPr/>
-        </p:nvSpPr>
-        <p:spPr>
-          <a:xfrm>
-            <a:off x="685800" y="5486400"/>
-            <a:ext cx="10817352" cy="640080"/>
-          </a:xfrm>
-          <a:prstGeom prst="rect">
-            <a:avLst/>
-          </a:prstGeom>
-          <a:solidFill>
-            <a:srgbClr val="1F2C56"/>
-          </a:solidFill>
-          <a:ln>
-            <a:noFill/>
-          </a:ln>
-        </p:spPr>
-        <p:style>
-          <a:lnRef idx="1">
-            <a:schemeClr val="accent1"/>
-          </a:lnRef>
-          <a:fillRef idx="3">
-            <a:schemeClr val="accent1"/>
-          </a:fillRef>
-          <a:effectRef idx="2">
-            <a:schemeClr val="accent1"/>
-          </a:effectRef>
-          <a:fontRef idx="minor">
-            <a:schemeClr val="lt1"/>
-          </a:fontRef>
-        </p:style>
-        <p:txBody>
-          <a:bodyPr rtlCol="0" anchor="ctr"/>
-          <a:lstStyle/>
-          <a:p>
-            <a:pPr algn="ctr"/>
-          </a:p>
-        </p:txBody>
-      </p:sp>
-      <p:sp>
-        <p:nvSpPr>
-          <p:cNvPr id="10" name="TextBox 9"/>
-          <p:cNvSpPr txBox="1"/>
-          <p:nvPr/>
-        </p:nvSpPr>
-        <p:spPr>
-          <a:xfrm>
-            <a:off x="868680" y="5596128"/>
-            <a:ext cx="10451592" cy="457200"/>
-          </a:xfrm>
-          <a:prstGeom prst="rect">
-            <a:avLst/>
-          </a:prstGeom>
-          <a:noFill/>
-        </p:spPr>
-        <p:txBody>
-          <a:bodyPr wrap="square">
-            <a:spAutoFit/>
-          </a:bodyPr>
-          <a:lstStyle/>
-          <a:p>
-            <a:pPr algn="l"/>
-            <a:r>
-              <a:rPr sz="1300" b="1" i="0">
-                <a:solidFill>
-                  <a:srgbClr val="FFFFFF"/>
-                </a:solidFill>
-                <a:latin typeface="Arial"/>
-              </a:rPr>
-              <a:t>→  Bearbeitung im Teilnehmer-Workbook (Arbeitsblatt mit Ausfüllfeldern)</a:t>
-            </a:r>
-          </a:p>
-        </p:txBody>
-      </p:sp>
-      <p:sp>
-        <p:nvSpPr>
-          <p:cNvPr id="11" name="Rectangle 10"/>
+      <p:pic>
+        <p:nvPicPr>
+          <p:cNvPr id="7" name="Picture 6" descr="image.png"/>
+          <p:cNvPicPr>
+            <a:picLocks noChangeAspect="1"/>
+          </p:cNvPicPr>
+          <p:nvPr/>
+        </p:nvPicPr>
+        <p:blipFill>
+          <a:blip r:embed="rId2"/>
+          <a:stretch>
+            <a:fillRect/>
+          </a:stretch>
+        </p:blipFill>
+        <p:spPr>
+          <a:xfrm>
+            <a:off x="2009463" y="1325880"/>
+            <a:ext cx="8170026" cy="4937760"/>
+          </a:xfrm>
+          <a:prstGeom prst="rect">
+            <a:avLst/>
+          </a:prstGeom>
+        </p:spPr>
+      </p:pic>
+      <p:sp>
+        <p:nvSpPr>
+          <p:cNvPr id="8" name="Rectangle 7"/>
           <p:cNvSpPr/>
           <p:nvPr/>
         </p:nvSpPr>
@@ -7087,7 +9880,7 @@
       </p:sp>
       <p:sp>
         <p:nvSpPr>
-          <p:cNvPr id="12" name="TextBox 11"/>
+          <p:cNvPr id="9" name="TextBox 8"/>
           <p:cNvSpPr txBox="1"/>
           <p:nvPr/>
         </p:nvSpPr>
@@ -7116,6 +9909,41 @@
                 <a:latin typeface="Consolas"/>
               </a:rPr>
               <a:t>FKB Campus  ·  VA01</a:t>
+            </a:r>
+          </a:p>
+        </p:txBody>
+      </p:sp>
+      <p:sp>
+        <p:nvSpPr>
+          <p:cNvPr id="10" name="TextBox 9"/>
+          <p:cNvSpPr txBox="1"/>
+          <p:nvPr/>
+        </p:nvSpPr>
+        <p:spPr>
+          <a:xfrm>
+            <a:off x="7176211" y="6583680"/>
+            <a:ext cx="4326940" cy="256032"/>
+          </a:xfrm>
+          <a:prstGeom prst="rect">
+            <a:avLst/>
+          </a:prstGeom>
+          <a:noFill/>
+        </p:spPr>
+        <p:txBody>
+          <a:bodyPr wrap="none">
+            <a:spAutoFit/>
+          </a:bodyPr>
+          <a:lstStyle/>
+          <a:p>
+            <a:pPr algn="r"/>
+            <a:r>
+              <a:rPr sz="700">
+                <a:solidFill>
+                  <a:srgbClr val="A0B4D2"/>
+                </a:solidFill>
+                <a:latin typeface="Consolas"/>
+              </a:rPr>
+              <a:t>Schaubild</a:t>
             </a:r>
           </a:p>
         </p:txBody>
@@ -7153,6 +9981,250 @@
             <a:avLst/>
           </a:prstGeom>
           <a:solidFill>
+            <a:srgbClr val="1F2C56"/>
+          </a:solidFill>
+          <a:ln>
+            <a:noFill/>
+          </a:ln>
+        </p:spPr>
+        <p:style>
+          <a:lnRef idx="1">
+            <a:schemeClr val="accent1"/>
+          </a:lnRef>
+          <a:fillRef idx="3">
+            <a:schemeClr val="accent1"/>
+          </a:fillRef>
+          <a:effectRef idx="2">
+            <a:schemeClr val="accent1"/>
+          </a:effectRef>
+          <a:fontRef idx="minor">
+            <a:schemeClr val="lt1"/>
+          </a:fontRef>
+        </p:style>
+        <p:txBody>
+          <a:bodyPr rtlCol="0" anchor="ctr"/>
+          <a:lstStyle/>
+          <a:p>
+            <a:pPr algn="ctr"/>
+          </a:p>
+        </p:txBody>
+      </p:sp>
+      <p:sp>
+        <p:nvSpPr>
+          <p:cNvPr id="3" name="TextBox 2"/>
+          <p:cNvSpPr txBox="1"/>
+          <p:nvPr/>
+        </p:nvSpPr>
+        <p:spPr>
+          <a:xfrm>
+            <a:off x="685800" y="2377440"/>
+            <a:ext cx="10817352" cy="365760"/>
+          </a:xfrm>
+          <a:prstGeom prst="rect">
+            <a:avLst/>
+          </a:prstGeom>
+          <a:noFill/>
+        </p:spPr>
+        <p:txBody>
+          <a:bodyPr wrap="none">
+            <a:spAutoFit/>
+          </a:bodyPr>
+          <a:lstStyle/>
+          <a:p>
+            <a:pPr algn="l"/>
+            <a:r>
+              <a:rPr sz="1200">
+                <a:solidFill>
+                  <a:srgbClr val="D9C089"/>
+                </a:solidFill>
+                <a:latin typeface="Consolas"/>
+              </a:rPr>
+              <a:t>00:20–00:30</a:t>
+            </a:r>
+          </a:p>
+        </p:txBody>
+      </p:sp>
+      <p:sp>
+        <p:nvSpPr>
+          <p:cNvPr id="4" name="Rectangle 3"/>
+          <p:cNvSpPr/>
+          <p:nvPr/>
+        </p:nvSpPr>
+        <p:spPr>
+          <a:xfrm>
+            <a:off x="685800" y="2788920"/>
+            <a:ext cx="548640" cy="38100"/>
+          </a:xfrm>
+          <a:prstGeom prst="rect">
+            <a:avLst/>
+          </a:prstGeom>
+          <a:solidFill>
+            <a:srgbClr val="D9C089"/>
+          </a:solidFill>
+          <a:ln>
+            <a:noFill/>
+          </a:ln>
+        </p:spPr>
+        <p:style>
+          <a:lnRef idx="1">
+            <a:schemeClr val="accent1"/>
+          </a:lnRef>
+          <a:fillRef idx="3">
+            <a:schemeClr val="accent1"/>
+          </a:fillRef>
+          <a:effectRef idx="2">
+            <a:schemeClr val="accent1"/>
+          </a:effectRef>
+          <a:fontRef idx="minor">
+            <a:schemeClr val="lt1"/>
+          </a:fontRef>
+        </p:style>
+        <p:txBody>
+          <a:bodyPr rtlCol="0" anchor="ctr"/>
+          <a:lstStyle/>
+          <a:p>
+            <a:pPr algn="ctr"/>
+          </a:p>
+        </p:txBody>
+      </p:sp>
+      <p:sp>
+        <p:nvSpPr>
+          <p:cNvPr id="5" name="TextBox 4"/>
+          <p:cNvSpPr txBox="1"/>
+          <p:nvPr/>
+        </p:nvSpPr>
+        <p:spPr>
+          <a:xfrm>
+            <a:off x="685800" y="3017520"/>
+            <a:ext cx="10817352" cy="1463040"/>
+          </a:xfrm>
+          <a:prstGeom prst="rect">
+            <a:avLst/>
+          </a:prstGeom>
+          <a:noFill/>
+        </p:spPr>
+        <p:txBody>
+          <a:bodyPr wrap="square">
+            <a:spAutoFit/>
+          </a:bodyPr>
+          <a:lstStyle/>
+          <a:p>
+            <a:pPr algn="l"/>
+            <a:r>
+              <a:rPr sz="4000" b="1" i="0">
+                <a:solidFill>
+                  <a:srgbClr val="FFFFFF"/>
+                </a:solidFill>
+                <a:latin typeface="Arial"/>
+              </a:rPr>
+              <a:t>Theorie-Input 2</a:t>
+            </a:r>
+          </a:p>
+        </p:txBody>
+      </p:sp>
+      <p:sp>
+        <p:nvSpPr>
+          <p:cNvPr id="6" name="TextBox 5"/>
+          <p:cNvSpPr txBox="1"/>
+          <p:nvPr/>
+        </p:nvSpPr>
+        <p:spPr>
+          <a:xfrm>
+            <a:off x="685800" y="4480560"/>
+            <a:ext cx="8653881" cy="1280160"/>
+          </a:xfrm>
+          <a:prstGeom prst="rect">
+            <a:avLst/>
+          </a:prstGeom>
+          <a:noFill/>
+        </p:spPr>
+        <p:txBody>
+          <a:bodyPr wrap="square">
+            <a:spAutoFit/>
+          </a:bodyPr>
+          <a:lstStyle/>
+          <a:p>
+            <a:pPr algn="l"/>
+            <a:r>
+              <a:rPr sz="1600" b="0" i="0">
+                <a:solidFill>
+                  <a:srgbClr val="C8D2E6"/>
+                </a:solidFill>
+                <a:latin typeface="Arial"/>
+              </a:rPr>
+              <a:t>Funktionstrennung Markt/Marktfolge und § 18 KWG in der eigenen Rolle verorten.</a:t>
+            </a:r>
+          </a:p>
+        </p:txBody>
+      </p:sp>
+      <p:sp>
+        <p:nvSpPr>
+          <p:cNvPr id="7" name="TextBox 6"/>
+          <p:cNvSpPr txBox="1"/>
+          <p:nvPr/>
+        </p:nvSpPr>
+        <p:spPr>
+          <a:xfrm>
+            <a:off x="685800" y="6355080"/>
+            <a:ext cx="10817352" cy="274320"/>
+          </a:xfrm>
+          <a:prstGeom prst="rect">
+            <a:avLst/>
+          </a:prstGeom>
+          <a:noFill/>
+        </p:spPr>
+        <p:txBody>
+          <a:bodyPr wrap="none">
+            <a:spAutoFit/>
+          </a:bodyPr>
+          <a:lstStyle/>
+          <a:p>
+            <a:pPr algn="l"/>
+            <a:r>
+              <a:rPr sz="700">
+                <a:solidFill>
+                  <a:srgbClr val="8CA0C3"/>
+                </a:solidFill>
+                <a:latin typeface="Consolas"/>
+              </a:rPr>
+              <a:t>FKB Campus  ·  VA01</a:t>
+            </a:r>
+          </a:p>
+        </p:txBody>
+      </p:sp>
+    </p:spTree>
+  </p:cSld>
+  <p:clrMapOvr>
+    <a:masterClrMapping/>
+  </p:clrMapOvr>
+</p:sld>
+</file>
+
+<file path=ppt/slides/slide9.xml><?xml version="1.0" encoding="utf-8"?>
+<p:sld xmlns:a="http://schemas.openxmlformats.org/drawingml/2006/main" xmlns:p="http://schemas.openxmlformats.org/presentationml/2006/main" xmlns:r="http://schemas.openxmlformats.org/officeDocument/2006/relationships">
+  <p:cSld>
+    <p:spTree>
+      <p:nvGrpSpPr>
+        <p:cNvPr id="1" name=""/>
+        <p:cNvGrpSpPr/>
+        <p:nvPr/>
+      </p:nvGrpSpPr>
+      <p:grpSpPr/>
+      <p:sp>
+        <p:nvSpPr>
+          <p:cNvPr id="2" name="Rectangle 1"/>
+          <p:cNvSpPr/>
+          <p:nvPr/>
+        </p:nvSpPr>
+        <p:spPr>
+          <a:xfrm>
+            <a:off x="0" y="0"/>
+            <a:ext cx="12188952" cy="6858000"/>
+          </a:xfrm>
+          <a:prstGeom prst="rect">
+            <a:avLst/>
+          </a:prstGeom>
+          <a:solidFill>
             <a:srgbClr val="EDEDF3"/>
           </a:solidFill>
           <a:ln>
@@ -7375,7 +10447,7 @@
                 </a:solidFill>
                 <a:latin typeface="Arial"/>
               </a:rPr>
-              <a:t>Reflexionsfragen</a:t>
+              <a:t>Funktionstrennung und § 18 KWG</a:t>
             </a:r>
           </a:p>
         </p:txBody>
@@ -7401,6 +10473,44 @@
             <a:spAutoFit/>
           </a:bodyPr>
           <a:lstStyle/>
+          <a:p>
+            <a:pPr marL="177800" indent="-177800">
+              <a:spcBef>
+                <a:spcPts val="600"/>
+              </a:spcBef>
+              <a:spcAft>
+                <a:spcPts val="200"/>
+              </a:spcAft>
+            </a:pPr>
+            <a:r>
+              <a:rPr sz="1200" i="1">
+                <a:solidFill>
+                  <a:srgbClr val="3D5466"/>
+                </a:solidFill>
+                <a:latin typeface="Arial"/>
+              </a:rPr>
+              <a:t>→  Die Trennung von Markt und Marktfolge (MaRisk BTO 1.2) sichert das Vier-Augen-Prinzip – der Innendienst ist die unabhängige zweite Instanz.</a:t>
+            </a:r>
+          </a:p>
+          <a:p>
+            <a:pPr>
+              <a:spcBef>
+                <a:spcPts val="1000"/>
+              </a:spcBef>
+              <a:spcAft>
+                <a:spcPts val="200"/>
+              </a:spcAft>
+            </a:pPr>
+            <a:r>
+              <a:rPr sz="800" b="1">
+                <a:solidFill>
+                  <a:srgbClr val="78808C"/>
+                </a:solidFill>
+                <a:latin typeface="Consolas"/>
+              </a:rPr>
+              <a:t>LAUFENDE OFFENLEGUNG NACH § 18 KWG</a:t>
+            </a:r>
+          </a:p>
           <a:p>
             <a:pPr marL="190500" indent="-190500">
               <a:spcBef>
@@ -7417,7 +10527,7 @@
                 </a:solidFill>
                 <a:latin typeface="Arial"/>
               </a:rPr>
-              <a:t>▸  Welche Unterlage fehlt in Ihrer Praxis am häufigsten – und woran liegt das?</a:t>
+              <a:t>▸  Ab 750.000 EUR Gesamtverschuldung muss sich die Bank die wirtschaftlichen Verhältnisse laufend offenlegen lassen – nicht nur bei Antragstellung.</a:t>
             </a:r>
           </a:p>
           <a:p>
@@ -7436,7 +10546,7 @@
                 </a:solidFill>
                 <a:latin typeface="Arial"/>
               </a:rPr>
-              <a:t>▸  Wie erklären Sie einem Berater freundlich, dass eine Akte vor der Auszahlung noch nicht vollständig ist?</a:t>
+              <a:t>▸  Dazu zählen aktuelle Jahresabschlüsse und unterjährige Auswertungen (BWA).</a:t>
             </a:r>
           </a:p>
           <a:p>
@@ -7455,26 +10565,7 @@
                 </a:solidFill>
                 <a:latin typeface="Arial"/>
               </a:rPr>
-              <a:t>▸  Woran erkennen Sie, dass eine Offenlegungsunterlage „nicht mehr aktuell genug" ist?</a:t>
-            </a:r>
-          </a:p>
-          <a:p>
-            <a:pPr marL="190500" indent="-190500">
-              <a:spcBef>
-                <a:spcPts val="400"/>
-              </a:spcBef>
-              <a:spcAft>
-                <a:spcPts val="200"/>
-              </a:spcAft>
-            </a:pPr>
-            <a:r>
-              <a:rPr sz="1300">
-                <a:solidFill>
-                  <a:srgbClr val="3D5466"/>
-                </a:solidFill>
-                <a:latin typeface="Arial"/>
-              </a:rPr>
-              <a:t>▸  Wie reagieren Sie, wenn ein Firmenkunde direkt bei Ihnen anruft und nach dem Stand seiner Auszahlung fragt – aber noch Unterlagen fehlen und der Berater im Termin ist?</a:t>
+              <a:t>▸  Fehlende Offenlegung ist ein klassischer Prüfungsmangel und im Innendienst der häufigste Nachforderungsgrund.</a:t>
             </a:r>
           </a:p>
         </p:txBody>

</xml_diff>